<commit_message>
Fix slide 3 layout — use positioned text boxes instead of monospace
Co-Authored-By: Claude Opus 4.6 (1M context) <noreply@anthropic.com>
</commit_message>
<xml_diff>
--- a/lectures/lecture17_full_picture.pptx
+++ b/lectures/lecture17_full_picture.pptx
@@ -7893,24 +7893,21 @@
         </p:nvSpPr>
         <p:spPr>
           <a:xfrm>
-            <a:off x="502920" y="914400"/>
-            <a:ext cx="8229600" cy="731520"/>
-          </a:xfrm>
-          <a:prstGeom prst="rect">
-            <a:avLst/>
-          </a:prstGeom>
-          <a:noFill/>
-        </p:spPr>
-        <p:txBody>
-          <a:bodyPr wrap="square">
-            <a:spAutoFit/>
-          </a:bodyPr>
-          <a:lstStyle/>
-          <a:p>
-            <a:pPr algn="l">
-              <a:spcAft>
-                <a:spcPts val="300"/>
-              </a:spcAft>
+            <a:off x="502920" y="685800"/>
+            <a:ext cx="8229600" cy="274320"/>
+          </a:xfrm>
+          <a:prstGeom prst="rect">
+            <a:avLst/>
+          </a:prstGeom>
+          <a:noFill/>
+        </p:spPr>
+        <p:txBody>
+          <a:bodyPr wrap="square">
+            <a:spAutoFit/>
+          </a:bodyPr>
+          <a:lstStyle/>
+          <a:p>
+            <a:pPr algn="l">
               <a:defRPr sz="1200" b="0">
                 <a:solidFill>
                   <a:srgbClr val="4A5568"/>
@@ -7919,7 +7916,7 @@
               </a:defRPr>
             </a:pPr>
             <a:r>
-              <a:t>Every technique maps to a phase:</a:t>
+              <a:t>Every technique maps to a phase of the agent lifecycle:</a:t>
             </a:r>
           </a:p>
         </p:txBody>
@@ -7932,142 +7929,1165 @@
         </p:nvSpPr>
         <p:spPr>
           <a:xfrm>
-            <a:off x="502920" y="1463040"/>
-            <a:ext cx="8229600" cy="3200400"/>
-          </a:xfrm>
-          <a:prstGeom prst="rect">
-            <a:avLst/>
-          </a:prstGeom>
-          <a:noFill/>
-        </p:spPr>
-        <p:txBody>
-          <a:bodyPr wrap="square">
-            <a:spAutoFit/>
-          </a:bodyPr>
-          <a:lstStyle/>
-          <a:p>
-            <a:pPr algn="l">
-              <a:spcAft>
-                <a:spcPts val="300"/>
-              </a:spcAft>
+            <a:off x="365760" y="1051560"/>
+            <a:ext cx="1554480" cy="274320"/>
+          </a:xfrm>
+          <a:prstGeom prst="rect">
+            <a:avLst/>
+          </a:prstGeom>
+          <a:noFill/>
+        </p:spPr>
+        <p:txBody>
+          <a:bodyPr wrap="square">
+            <a:spAutoFit/>
+          </a:bodyPr>
+          <a:lstStyle/>
+          <a:p>
+            <a:pPr algn="l">
               <a:defRPr sz="1300" b="1">
                 <a:solidFill>
                   <a:srgbClr val="0E7C7B"/>
                 </a:solidFill>
+                <a:latin typeface="Trebuchet MS"/>
+              </a:defRPr>
+            </a:pPr>
+            <a:r>
+              <a:t>DESIGN</a:t>
+            </a:r>
+          </a:p>
+        </p:txBody>
+      </p:sp>
+      <p:sp>
+        <p:nvSpPr>
+          <p:cNvPr id="8" name="TextBox 7"/>
+          <p:cNvSpPr txBox="1"/>
+          <p:nvPr/>
+        </p:nvSpPr>
+        <p:spPr>
+          <a:xfrm>
+            <a:off x="2011680" y="1051560"/>
+            <a:ext cx="1554480" cy="274320"/>
+          </a:xfrm>
+          <a:prstGeom prst="rect">
+            <a:avLst/>
+          </a:prstGeom>
+          <a:noFill/>
+        </p:spPr>
+        <p:txBody>
+          <a:bodyPr wrap="square">
+            <a:spAutoFit/>
+          </a:bodyPr>
+          <a:lstStyle/>
+          <a:p>
+            <a:pPr algn="l">
+              <a:defRPr sz="1300" b="1">
+                <a:solidFill>
+                  <a:srgbClr val="0E7C7B"/>
+                </a:solidFill>
+                <a:latin typeface="Trebuchet MS"/>
+              </a:defRPr>
+            </a:pPr>
+            <a:r>
+              <a:t>BUILD</a:t>
+            </a:r>
+          </a:p>
+        </p:txBody>
+      </p:sp>
+      <p:sp>
+        <p:nvSpPr>
+          <p:cNvPr id="9" name="TextBox 8"/>
+          <p:cNvSpPr txBox="1"/>
+          <p:nvPr/>
+        </p:nvSpPr>
+        <p:spPr>
+          <a:xfrm>
+            <a:off x="3657600" y="1051560"/>
+            <a:ext cx="1554480" cy="274320"/>
+          </a:xfrm>
+          <a:prstGeom prst="rect">
+            <a:avLst/>
+          </a:prstGeom>
+          <a:noFill/>
+        </p:spPr>
+        <p:txBody>
+          <a:bodyPr wrap="square">
+            <a:spAutoFit/>
+          </a:bodyPr>
+          <a:lstStyle/>
+          <a:p>
+            <a:pPr algn="l">
+              <a:defRPr sz="1300" b="1">
+                <a:solidFill>
+                  <a:srgbClr val="0E7C7B"/>
+                </a:solidFill>
+                <a:latin typeface="Trebuchet MS"/>
+              </a:defRPr>
+            </a:pPr>
+            <a:r>
+              <a:t>AUDIT</a:t>
+            </a:r>
+          </a:p>
+        </p:txBody>
+      </p:sp>
+      <p:sp>
+        <p:nvSpPr>
+          <p:cNvPr id="10" name="TextBox 9"/>
+          <p:cNvSpPr txBox="1"/>
+          <p:nvPr/>
+        </p:nvSpPr>
+        <p:spPr>
+          <a:xfrm>
+            <a:off x="5303520" y="1051560"/>
+            <a:ext cx="1554480" cy="274320"/>
+          </a:xfrm>
+          <a:prstGeom prst="rect">
+            <a:avLst/>
+          </a:prstGeom>
+          <a:noFill/>
+        </p:spPr>
+        <p:txBody>
+          <a:bodyPr wrap="square">
+            <a:spAutoFit/>
+          </a:bodyPr>
+          <a:lstStyle/>
+          <a:p>
+            <a:pPr algn="l">
+              <a:defRPr sz="1300" b="1">
+                <a:solidFill>
+                  <a:srgbClr val="0E7C7B"/>
+                </a:solidFill>
+                <a:latin typeface="Trebuchet MS"/>
+              </a:defRPr>
+            </a:pPr>
+            <a:r>
+              <a:t>DEPLOY</a:t>
+            </a:r>
+          </a:p>
+        </p:txBody>
+      </p:sp>
+      <p:sp>
+        <p:nvSpPr>
+          <p:cNvPr id="11" name="TextBox 10"/>
+          <p:cNvSpPr txBox="1"/>
+          <p:nvPr/>
+        </p:nvSpPr>
+        <p:spPr>
+          <a:xfrm>
+            <a:off x="7040880" y="1051560"/>
+            <a:ext cx="1554480" cy="274320"/>
+          </a:xfrm>
+          <a:prstGeom prst="rect">
+            <a:avLst/>
+          </a:prstGeom>
+          <a:noFill/>
+        </p:spPr>
+        <p:txBody>
+          <a:bodyPr wrap="square">
+            <a:spAutoFit/>
+          </a:bodyPr>
+          <a:lstStyle/>
+          <a:p>
+            <a:pPr algn="l">
+              <a:defRPr sz="1300" b="1">
+                <a:solidFill>
+                  <a:srgbClr val="0E7C7B"/>
+                </a:solidFill>
+                <a:latin typeface="Trebuchet MS"/>
+              </a:defRPr>
+            </a:pPr>
+            <a:r>
+              <a:t>MONITOR</a:t>
+            </a:r>
+          </a:p>
+        </p:txBody>
+      </p:sp>
+      <p:sp>
+        <p:nvSpPr>
+          <p:cNvPr id="12" name="TextBox 11"/>
+          <p:cNvSpPr txBox="1"/>
+          <p:nvPr/>
+        </p:nvSpPr>
+        <p:spPr>
+          <a:xfrm>
+            <a:off x="365760" y="1353312"/>
+            <a:ext cx="8229600" cy="137160"/>
+          </a:xfrm>
+          <a:prstGeom prst="rect">
+            <a:avLst/>
+          </a:prstGeom>
+          <a:noFill/>
+        </p:spPr>
+        <p:txBody>
+          <a:bodyPr wrap="square">
+            <a:spAutoFit/>
+          </a:bodyPr>
+          <a:lstStyle/>
+          <a:p>
+            <a:pPr algn="l">
+              <a:defRPr sz="800" b="0">
+                <a:solidFill>
+                  <a:srgbClr val="0E7C7B"/>
+                </a:solidFill>
+                <a:latin typeface="Trebuchet MS"/>
+              </a:defRPr>
+            </a:pPr>
+            <a:r>
+              <a:t>────────────────────────────────────────────────────────────────────────────────</a:t>
+            </a:r>
+          </a:p>
+        </p:txBody>
+      </p:sp>
+      <p:sp>
+        <p:nvSpPr>
+          <p:cNvPr id="13" name="TextBox 12"/>
+          <p:cNvSpPr txBox="1"/>
+          <p:nvPr/>
+        </p:nvSpPr>
+        <p:spPr>
+          <a:xfrm>
+            <a:off x="365760" y="1508760"/>
+            <a:ext cx="1554480" cy="274320"/>
+          </a:xfrm>
+          <a:prstGeom prst="rect">
+            <a:avLst/>
+          </a:prstGeom>
+          <a:noFill/>
+        </p:spPr>
+        <p:txBody>
+          <a:bodyPr wrap="square">
+            <a:spAutoFit/>
+          </a:bodyPr>
+          <a:lstStyle/>
+          <a:p>
+            <a:pPr algn="l">
+              <a:defRPr sz="1100" b="1">
+                <a:solidFill>
+                  <a:srgbClr val="1B2A4A"/>
+                </a:solidFill>
+                <a:latin typeface="Trebuchet MS"/>
+              </a:defRPr>
+            </a:pPr>
+            <a:r>
+              <a:t>Hoare triples</a:t>
+            </a:r>
+          </a:p>
+        </p:txBody>
+      </p:sp>
+      <p:sp>
+        <p:nvSpPr>
+          <p:cNvPr id="14" name="TextBox 13"/>
+          <p:cNvSpPr txBox="1"/>
+          <p:nvPr/>
+        </p:nvSpPr>
+        <p:spPr>
+          <a:xfrm>
+            <a:off x="2011680" y="1508760"/>
+            <a:ext cx="1554480" cy="274320"/>
+          </a:xfrm>
+          <a:prstGeom prst="rect">
+            <a:avLst/>
+          </a:prstGeom>
+          <a:noFill/>
+        </p:spPr>
+        <p:txBody>
+          <a:bodyPr wrap="square">
+            <a:spAutoFit/>
+          </a:bodyPr>
+          <a:lstStyle/>
+          <a:p>
+            <a:pPr algn="l">
+              <a:defRPr sz="1100" b="1">
+                <a:solidFill>
+                  <a:srgbClr val="1B2A4A"/>
+                </a:solidFill>
+                <a:latin typeface="Trebuchet MS"/>
+              </a:defRPr>
+            </a:pPr>
+            <a:r>
+              <a:t>VCG + Z3</a:t>
+            </a:r>
+          </a:p>
+        </p:txBody>
+      </p:sp>
+      <p:sp>
+        <p:nvSpPr>
+          <p:cNvPr id="15" name="TextBox 14"/>
+          <p:cNvSpPr txBox="1"/>
+          <p:nvPr/>
+        </p:nvSpPr>
+        <p:spPr>
+          <a:xfrm>
+            <a:off x="3657600" y="1508760"/>
+            <a:ext cx="1554480" cy="274320"/>
+          </a:xfrm>
+          <a:prstGeom prst="rect">
+            <a:avLst/>
+          </a:prstGeom>
+          <a:noFill/>
+        </p:spPr>
+        <p:txBody>
+          <a:bodyPr wrap="square">
+            <a:spAutoFit/>
+          </a:bodyPr>
+          <a:lstStyle/>
+          <a:p>
+            <a:pPr algn="l">
+              <a:defRPr sz="1100" b="1">
+                <a:solidFill>
+                  <a:srgbClr val="1B2A4A"/>
+                </a:solidFill>
+                <a:latin typeface="Trebuchet MS"/>
+              </a:defRPr>
+            </a:pPr>
+            <a:r>
+              <a:t>Static analysis</a:t>
+            </a:r>
+          </a:p>
+        </p:txBody>
+      </p:sp>
+      <p:sp>
+        <p:nvSpPr>
+          <p:cNvPr id="16" name="TextBox 15"/>
+          <p:cNvSpPr txBox="1"/>
+          <p:nvPr/>
+        </p:nvSpPr>
+        <p:spPr>
+          <a:xfrm>
+            <a:off x="5303520" y="1508760"/>
+            <a:ext cx="1554480" cy="274320"/>
+          </a:xfrm>
+          <a:prstGeom prst="rect">
+            <a:avLst/>
+          </a:prstGeom>
+          <a:noFill/>
+        </p:spPr>
+        <p:txBody>
+          <a:bodyPr wrap="square">
+            <a:spAutoFit/>
+          </a:bodyPr>
+          <a:lstStyle/>
+          <a:p>
+            <a:pPr algn="l">
+              <a:defRPr sz="1100" b="1">
+                <a:solidFill>
+                  <a:srgbClr val="1B2A4A"/>
+                </a:solidFill>
+                <a:latin typeface="Trebuchet MS"/>
+              </a:defRPr>
+            </a:pPr>
+            <a:r>
+              <a:t>DFA monitors</a:t>
+            </a:r>
+          </a:p>
+        </p:txBody>
+      </p:sp>
+      <p:sp>
+        <p:nvSpPr>
+          <p:cNvPr id="17" name="TextBox 16"/>
+          <p:cNvSpPr txBox="1"/>
+          <p:nvPr/>
+        </p:nvSpPr>
+        <p:spPr>
+          <a:xfrm>
+            <a:off x="7040880" y="1508760"/>
+            <a:ext cx="1554480" cy="274320"/>
+          </a:xfrm>
+          <a:prstGeom prst="rect">
+            <a:avLst/>
+          </a:prstGeom>
+          <a:noFill/>
+        </p:spPr>
+        <p:txBody>
+          <a:bodyPr wrap="square">
+            <a:spAutoFit/>
+          </a:bodyPr>
+          <a:lstStyle/>
+          <a:p>
+            <a:pPr algn="l">
+              <a:defRPr sz="1100" b="1">
+                <a:solidFill>
+                  <a:srgbClr val="1B2A4A"/>
+                </a:solidFill>
+                <a:latin typeface="Trebuchet MS"/>
+              </a:defRPr>
+            </a:pPr>
+            <a:r>
+              <a:t>Trace verif.</a:t>
+            </a:r>
+          </a:p>
+        </p:txBody>
+      </p:sp>
+      <p:sp>
+        <p:nvSpPr>
+          <p:cNvPr id="18" name="TextBox 17"/>
+          <p:cNvSpPr txBox="1"/>
+          <p:nvPr/>
+        </p:nvSpPr>
+        <p:spPr>
+          <a:xfrm>
+            <a:off x="365760" y="1783080"/>
+            <a:ext cx="1554480" cy="274320"/>
+          </a:xfrm>
+          <a:prstGeom prst="rect">
+            <a:avLst/>
+          </a:prstGeom>
+          <a:noFill/>
+        </p:spPr>
+        <p:txBody>
+          <a:bodyPr wrap="square">
+            <a:spAutoFit/>
+          </a:bodyPr>
+          <a:lstStyle/>
+          <a:p>
+            <a:pPr algn="l">
+              <a:defRPr sz="1000" b="0">
+                <a:solidFill>
+                  <a:srgbClr val="4A5568"/>
+                </a:solidFill>
                 <a:latin typeface="Courier New"/>
               </a:defRPr>
             </a:pPr>
             <a:r>
-              <a:t>DESIGN              BUILD              AUDIT              DEPLOY             MONITOR</a:t>
-            </a:r>
-          </a:p>
-          <a:p>
-            <a:pPr algn="l">
-              <a:spcAft>
-                <a:spcPts val="300"/>
-              </a:spcAft>
+              <a:t>{P} C {Q}</a:t>
+            </a:r>
+          </a:p>
+        </p:txBody>
+      </p:sp>
+      <p:sp>
+        <p:nvSpPr>
+          <p:cNvPr id="19" name="TextBox 18"/>
+          <p:cNvSpPr txBox="1"/>
+          <p:nvPr/>
+        </p:nvSpPr>
+        <p:spPr>
+          <a:xfrm>
+            <a:off x="2011680" y="1783080"/>
+            <a:ext cx="1554480" cy="274320"/>
+          </a:xfrm>
+          <a:prstGeom prst="rect">
+            <a:avLst/>
+          </a:prstGeom>
+          <a:noFill/>
+        </p:spPr>
+        <p:txBody>
+          <a:bodyPr wrap="square">
+            <a:spAutoFit/>
+          </a:bodyPr>
+          <a:lstStyle/>
+          <a:p>
+            <a:pPr algn="l">
               <a:defRPr sz="1000" b="0">
                 <a:solidFill>
-                  <a:srgbClr val="0E7C7B"/>
-                </a:solidFill>
-                <a:latin typeface="Trebuchet MS"/>
-              </a:defRPr>
-            </a:pPr>
-            <a:r>
-              <a:t>─────────────────────────────────────────────────────────────────</a:t>
-            </a:r>
-          </a:p>
-          <a:p>
-            <a:pPr algn="l">
-              <a:spcAft>
-                <a:spcPts val="300"/>
+                  <a:srgbClr val="4A5568"/>
+                </a:solidFill>
+                <a:latin typeface="Courier New"/>
+              </a:defRPr>
+            </a:pPr>
+            <a:r>
+              <a:t>wp()</a:t>
+            </a:r>
+          </a:p>
+        </p:txBody>
+      </p:sp>
+      <p:sp>
+        <p:nvSpPr>
+          <p:cNvPr id="20" name="TextBox 19"/>
+          <p:cNvSpPr txBox="1"/>
+          <p:nvPr/>
+        </p:nvSpPr>
+        <p:spPr>
+          <a:xfrm>
+            <a:off x="3657600" y="1783080"/>
+            <a:ext cx="1554480" cy="274320"/>
+          </a:xfrm>
+          <a:prstGeom prst="rect">
+            <a:avLst/>
+          </a:prstGeom>
+          <a:noFill/>
+        </p:spPr>
+        <p:txBody>
+          <a:bodyPr wrap="square">
+            <a:spAutoFit/>
+          </a:bodyPr>
+          <a:lstStyle/>
+          <a:p>
+            <a:pPr algn="l">
+              <a:defRPr sz="1000" b="0">
+                <a:solidFill>
+                  <a:srgbClr val="4A5568"/>
+                </a:solidFill>
+                <a:latin typeface="Courier New"/>
+              </a:defRPr>
+            </a:pPr>
+            <a:r>
+              <a:t>Datalog</a:t>
+            </a:r>
+          </a:p>
+        </p:txBody>
+      </p:sp>
+      <p:sp>
+        <p:nvSpPr>
+          <p:cNvPr id="21" name="TextBox 20"/>
+          <p:cNvSpPr txBox="1"/>
+          <p:nvPr/>
+        </p:nvSpPr>
+        <p:spPr>
+          <a:xfrm>
+            <a:off x="5303520" y="1783080"/>
+            <a:ext cx="1554480" cy="274320"/>
+          </a:xfrm>
+          <a:prstGeom prst="rect">
+            <a:avLst/>
+          </a:prstGeom>
+          <a:noFill/>
+        </p:spPr>
+        <p:txBody>
+          <a:bodyPr wrap="square">
+            <a:spAutoFit/>
+          </a:bodyPr>
+          <a:lstStyle/>
+          <a:p>
+            <a:pPr algn="l">
+              <a:defRPr sz="1000" b="0">
+                <a:solidFill>
+                  <a:srgbClr val="4A5568"/>
+                </a:solidFill>
+                <a:latin typeface="Courier New"/>
+              </a:defRPr>
+            </a:pPr>
+            <a:r>
+              <a:t>ALLOW/DENY</a:t>
+            </a:r>
+          </a:p>
+        </p:txBody>
+      </p:sp>
+      <p:sp>
+        <p:nvSpPr>
+          <p:cNvPr id="22" name="TextBox 21"/>
+          <p:cNvSpPr txBox="1"/>
+          <p:nvPr/>
+        </p:nvSpPr>
+        <p:spPr>
+          <a:xfrm>
+            <a:off x="7040880" y="1783080"/>
+            <a:ext cx="1554480" cy="274320"/>
+          </a:xfrm>
+          <a:prstGeom prst="rect">
+            <a:avLst/>
+          </a:prstGeom>
+          <a:noFill/>
+        </p:spPr>
+        <p:txBody>
+          <a:bodyPr wrap="square">
+            <a:spAutoFit/>
+          </a:bodyPr>
+          <a:lstStyle/>
+          <a:p>
+            <a:pPr algn="l">
+              <a:defRPr sz="1000" b="0">
+                <a:solidFill>
+                  <a:srgbClr val="4A5568"/>
+                </a:solidFill>
+                <a:latin typeface="Courier New"/>
+              </a:defRPr>
+            </a:pPr>
+            <a:r>
+              <a:t>safety/liveness</a:t>
+            </a:r>
+          </a:p>
+        </p:txBody>
+      </p:sp>
+      <p:sp>
+        <p:nvSpPr>
+          <p:cNvPr id="23" name="TextBox 22"/>
+          <p:cNvSpPr txBox="1"/>
+          <p:nvPr/>
+        </p:nvSpPr>
+        <p:spPr>
+          <a:xfrm>
+            <a:off x="365760" y="2057400"/>
+            <a:ext cx="1554480" cy="228600"/>
+          </a:xfrm>
+          <a:prstGeom prst="rect">
+            <a:avLst/>
+          </a:prstGeom>
+          <a:noFill/>
+        </p:spPr>
+        <p:txBody>
+          <a:bodyPr wrap="square">
+            <a:spAutoFit/>
+          </a:bodyPr>
+          <a:lstStyle/>
+          <a:p>
+            <a:pPr algn="l">
+              <a:defRPr sz="900" b="0">
+                <a:solidFill>
+                  <a:srgbClr val="8A95A7"/>
+                </a:solidFill>
+                <a:latin typeface="Trebuchet MS"/>
+              </a:defRPr>
+            </a:pPr>
+            <a:r>
+              <a:t>Lec 5–6</a:t>
+            </a:r>
+          </a:p>
+        </p:txBody>
+      </p:sp>
+      <p:sp>
+        <p:nvSpPr>
+          <p:cNvPr id="24" name="TextBox 23"/>
+          <p:cNvSpPr txBox="1"/>
+          <p:nvPr/>
+        </p:nvSpPr>
+        <p:spPr>
+          <a:xfrm>
+            <a:off x="2011680" y="2057400"/>
+            <a:ext cx="1554480" cy="228600"/>
+          </a:xfrm>
+          <a:prstGeom prst="rect">
+            <a:avLst/>
+          </a:prstGeom>
+          <a:noFill/>
+        </p:spPr>
+        <p:txBody>
+          <a:bodyPr wrap="square">
+            <a:spAutoFit/>
+          </a:bodyPr>
+          <a:lstStyle/>
+          <a:p>
+            <a:pPr algn="l">
+              <a:defRPr sz="900" b="0">
+                <a:solidFill>
+                  <a:srgbClr val="8A95A7"/>
+                </a:solidFill>
+                <a:latin typeface="Trebuchet MS"/>
+              </a:defRPr>
+            </a:pPr>
+            <a:r>
+              <a:t>Lec 6–7</a:t>
+            </a:r>
+          </a:p>
+        </p:txBody>
+      </p:sp>
+      <p:sp>
+        <p:nvSpPr>
+          <p:cNvPr id="25" name="TextBox 24"/>
+          <p:cNvSpPr txBox="1"/>
+          <p:nvPr/>
+        </p:nvSpPr>
+        <p:spPr>
+          <a:xfrm>
+            <a:off x="3657600" y="2057400"/>
+            <a:ext cx="1554480" cy="228600"/>
+          </a:xfrm>
+          <a:prstGeom prst="rect">
+            <a:avLst/>
+          </a:prstGeom>
+          <a:noFill/>
+        </p:spPr>
+        <p:txBody>
+          <a:bodyPr wrap="square">
+            <a:spAutoFit/>
+          </a:bodyPr>
+          <a:lstStyle/>
+          <a:p>
+            <a:pPr algn="l">
+              <a:defRPr sz="900" b="0">
+                <a:solidFill>
+                  <a:srgbClr val="8A95A7"/>
+                </a:solidFill>
+                <a:latin typeface="Trebuchet MS"/>
+              </a:defRPr>
+            </a:pPr>
+            <a:r>
+              <a:t>Lec 8–9</a:t>
+            </a:r>
+          </a:p>
+        </p:txBody>
+      </p:sp>
+      <p:sp>
+        <p:nvSpPr>
+          <p:cNvPr id="26" name="TextBox 25"/>
+          <p:cNvSpPr txBox="1"/>
+          <p:nvPr/>
+        </p:nvSpPr>
+        <p:spPr>
+          <a:xfrm>
+            <a:off x="5303520" y="2057400"/>
+            <a:ext cx="1554480" cy="228600"/>
+          </a:xfrm>
+          <a:prstGeom prst="rect">
+            <a:avLst/>
+          </a:prstGeom>
+          <a:noFill/>
+        </p:spPr>
+        <p:txBody>
+          <a:bodyPr wrap="square">
+            <a:spAutoFit/>
+          </a:bodyPr>
+          <a:lstStyle/>
+          <a:p>
+            <a:pPr algn="l">
+              <a:defRPr sz="900" b="0">
+                <a:solidFill>
+                  <a:srgbClr val="8A95A7"/>
+                </a:solidFill>
+                <a:latin typeface="Trebuchet MS"/>
+              </a:defRPr>
+            </a:pPr>
+            <a:r>
+              <a:t>Lec 10</a:t>
+            </a:r>
+          </a:p>
+        </p:txBody>
+      </p:sp>
+      <p:sp>
+        <p:nvSpPr>
+          <p:cNvPr id="27" name="TextBox 26"/>
+          <p:cNvSpPr txBox="1"/>
+          <p:nvPr/>
+        </p:nvSpPr>
+        <p:spPr>
+          <a:xfrm>
+            <a:off x="7040880" y="2057400"/>
+            <a:ext cx="1554480" cy="228600"/>
+          </a:xfrm>
+          <a:prstGeom prst="rect">
+            <a:avLst/>
+          </a:prstGeom>
+          <a:noFill/>
+        </p:spPr>
+        <p:txBody>
+          <a:bodyPr wrap="square">
+            <a:spAutoFit/>
+          </a:bodyPr>
+          <a:lstStyle/>
+          <a:p>
+            <a:pPr algn="l">
+              <a:defRPr sz="900" b="0">
+                <a:solidFill>
+                  <a:srgbClr val="8A95A7"/>
+                </a:solidFill>
+                <a:latin typeface="Trebuchet MS"/>
+              </a:defRPr>
+            </a:pPr>
+            <a:r>
+              <a:t>Lec 10</a:t>
+            </a:r>
+          </a:p>
+        </p:txBody>
+      </p:sp>
+      <p:sp>
+        <p:nvSpPr>
+          <p:cNvPr id="28" name="TextBox 27"/>
+          <p:cNvSpPr txBox="1"/>
+          <p:nvPr/>
+        </p:nvSpPr>
+        <p:spPr>
+          <a:xfrm>
+            <a:off x="365760" y="2423160"/>
+            <a:ext cx="8229600" cy="137160"/>
+          </a:xfrm>
+          <a:prstGeom prst="rect">
+            <a:avLst/>
+          </a:prstGeom>
+          <a:noFill/>
+        </p:spPr>
+        <p:txBody>
+          <a:bodyPr wrap="square">
+            <a:spAutoFit/>
+          </a:bodyPr>
+          <a:lstStyle/>
+          <a:p>
+            <a:pPr algn="l">
+              <a:defRPr sz="800" b="0">
+                <a:solidFill>
+                  <a:srgbClr val="DDDDDD"/>
+                </a:solidFill>
+                <a:latin typeface="Trebuchet MS"/>
+              </a:defRPr>
+            </a:pPr>
+            <a:r>
+              <a:t>────────────────────────────────────────────────────────────────────────────────</a:t>
+            </a:r>
+          </a:p>
+        </p:txBody>
+      </p:sp>
+      <p:sp>
+        <p:nvSpPr>
+          <p:cNvPr id="29" name="TextBox 28"/>
+          <p:cNvSpPr txBox="1"/>
+          <p:nvPr/>
+        </p:nvSpPr>
+        <p:spPr>
+          <a:xfrm>
+            <a:off x="365760" y="2606040"/>
+            <a:ext cx="1554480" cy="274320"/>
+          </a:xfrm>
+          <a:prstGeom prst="rect">
+            <a:avLst/>
+          </a:prstGeom>
+          <a:noFill/>
+        </p:spPr>
+        <p:txBody>
+          <a:bodyPr wrap="square">
+            <a:spAutoFit/>
+          </a:bodyPr>
+          <a:lstStyle/>
+          <a:p>
+            <a:pPr algn="l">
+              <a:defRPr sz="1300" b="1">
+                <a:solidFill>
+                  <a:srgbClr val="E67E22"/>
+                </a:solidFill>
+                <a:latin typeface="Trebuchet MS"/>
+              </a:defRPr>
+            </a:pPr>
+            <a:r>
+              <a:t>HW1</a:t>
+            </a:r>
+          </a:p>
+        </p:txBody>
+      </p:sp>
+      <p:sp>
+        <p:nvSpPr>
+          <p:cNvPr id="30" name="TextBox 29"/>
+          <p:cNvSpPr txBox="1"/>
+          <p:nvPr/>
+        </p:nvSpPr>
+        <p:spPr>
+          <a:xfrm>
+            <a:off x="365760" y="2880360"/>
+            <a:ext cx="1554480" cy="274320"/>
+          </a:xfrm>
+          <a:prstGeom prst="rect">
+            <a:avLst/>
+          </a:prstGeom>
+          <a:noFill/>
+        </p:spPr>
+        <p:txBody>
+          <a:bodyPr wrap="square">
+            <a:spAutoFit/>
+          </a:bodyPr>
+          <a:lstStyle/>
+          <a:p>
+            <a:pPr algn="l">
+              <a:defRPr sz="1000" b="0">
+                <a:solidFill>
+                  <a:srgbClr val="4A5568"/>
+                </a:solidFill>
+                <a:latin typeface="Trebuchet MS"/>
+              </a:defRPr>
+            </a:pPr>
+            <a:r>
+              <a:t>Build a skill</a:t>
+            </a:r>
+          </a:p>
+        </p:txBody>
+      </p:sp>
+      <p:sp>
+        <p:nvSpPr>
+          <p:cNvPr id="31" name="TextBox 30"/>
+          <p:cNvSpPr txBox="1"/>
+          <p:nvPr/>
+        </p:nvSpPr>
+        <p:spPr>
+          <a:xfrm>
+            <a:off x="2011680" y="2606040"/>
+            <a:ext cx="1554480" cy="274320"/>
+          </a:xfrm>
+          <a:prstGeom prst="rect">
+            <a:avLst/>
+          </a:prstGeom>
+          <a:noFill/>
+        </p:spPr>
+        <p:txBody>
+          <a:bodyPr wrap="square">
+            <a:spAutoFit/>
+          </a:bodyPr>
+          <a:lstStyle/>
+          <a:p>
+            <a:pPr algn="l">
+              <a:defRPr sz="1300" b="1">
+                <a:solidFill>
+                  <a:srgbClr val="E67E22"/>
+                </a:solidFill>
+                <a:latin typeface="Trebuchet MS"/>
+              </a:defRPr>
+            </a:pPr>
+            <a:r>
+              <a:t>HW2</a:t>
+            </a:r>
+          </a:p>
+        </p:txBody>
+      </p:sp>
+      <p:sp>
+        <p:nvSpPr>
+          <p:cNvPr id="32" name="TextBox 31"/>
+          <p:cNvSpPr txBox="1"/>
+          <p:nvPr/>
+        </p:nvSpPr>
+        <p:spPr>
+          <a:xfrm>
+            <a:off x="2011680" y="2880360"/>
+            <a:ext cx="1554480" cy="274320"/>
+          </a:xfrm>
+          <a:prstGeom prst="rect">
+            <a:avLst/>
+          </a:prstGeom>
+          <a:noFill/>
+        </p:spPr>
+        <p:txBody>
+          <a:bodyPr wrap="square">
+            <a:spAutoFit/>
+          </a:bodyPr>
+          <a:lstStyle/>
+          <a:p>
+            <a:pPr algn="l">
+              <a:defRPr sz="1000" b="0">
+                <a:solidFill>
+                  <a:srgbClr val="4A5568"/>
+                </a:solidFill>
+                <a:latin typeface="Trebuchet MS"/>
+              </a:defRPr>
+            </a:pPr>
+            <a:r>
+              <a:t>Verify programs</a:t>
+            </a:r>
+          </a:p>
+        </p:txBody>
+      </p:sp>
+      <p:sp>
+        <p:nvSpPr>
+          <p:cNvPr id="33" name="TextBox 32"/>
+          <p:cNvSpPr txBox="1"/>
+          <p:nvPr/>
+        </p:nvSpPr>
+        <p:spPr>
+          <a:xfrm>
+            <a:off x="3657600" y="2606040"/>
+            <a:ext cx="1554480" cy="274320"/>
+          </a:xfrm>
+          <a:prstGeom prst="rect">
+            <a:avLst/>
+          </a:prstGeom>
+          <a:noFill/>
+        </p:spPr>
+        <p:txBody>
+          <a:bodyPr wrap="square">
+            <a:spAutoFit/>
+          </a:bodyPr>
+          <a:lstStyle/>
+          <a:p>
+            <a:pPr algn="l">
+              <a:defRPr sz="1300" b="1">
+                <a:solidFill>
+                  <a:srgbClr val="E67E22"/>
+                </a:solidFill>
+                <a:latin typeface="Trebuchet MS"/>
+              </a:defRPr>
+            </a:pPr>
+            <a:r>
+              <a:t>HW3</a:t>
+            </a:r>
+          </a:p>
+        </p:txBody>
+      </p:sp>
+      <p:sp>
+        <p:nvSpPr>
+          <p:cNvPr id="34" name="TextBox 33"/>
+          <p:cNvSpPr txBox="1"/>
+          <p:nvPr/>
+        </p:nvSpPr>
+        <p:spPr>
+          <a:xfrm>
+            <a:off x="3657600" y="2880360"/>
+            <a:ext cx="1554480" cy="274320"/>
+          </a:xfrm>
+          <a:prstGeom prst="rect">
+            <a:avLst/>
+          </a:prstGeom>
+          <a:noFill/>
+        </p:spPr>
+        <p:txBody>
+          <a:bodyPr wrap="square">
+            <a:spAutoFit/>
+          </a:bodyPr>
+          <a:lstStyle/>
+          <a:p>
+            <a:pPr algn="l">
+              <a:defRPr sz="1000" b="0">
+                <a:solidFill>
+                  <a:srgbClr val="4A5568"/>
+                </a:solidFill>
+                <a:latin typeface="Trebuchet MS"/>
+              </a:defRPr>
+            </a:pPr>
+            <a:r>
+              <a:t>Audit skills</a:t>
+            </a:r>
+          </a:p>
+        </p:txBody>
+      </p:sp>
+      <p:sp>
+        <p:nvSpPr>
+          <p:cNvPr id="35" name="TextBox 34"/>
+          <p:cNvSpPr txBox="1"/>
+          <p:nvPr/>
+        </p:nvSpPr>
+        <p:spPr>
+          <a:xfrm>
+            <a:off x="5303520" y="2606040"/>
+            <a:ext cx="1554480" cy="274320"/>
+          </a:xfrm>
+          <a:prstGeom prst="rect">
+            <a:avLst/>
+          </a:prstGeom>
+          <a:noFill/>
+        </p:spPr>
+        <p:txBody>
+          <a:bodyPr wrap="square">
+            <a:spAutoFit/>
+          </a:bodyPr>
+          <a:lstStyle/>
+          <a:p>
+            <a:pPr algn="l">
+              <a:defRPr sz="1300" b="1">
+                <a:solidFill>
+                  <a:srgbClr val="E67E22"/>
+                </a:solidFill>
+                <a:latin typeface="Trebuchet MS"/>
+              </a:defRPr>
+            </a:pPr>
+            <a:r>
+              <a:t>HW4</a:t>
+            </a:r>
+          </a:p>
+        </p:txBody>
+      </p:sp>
+      <p:sp>
+        <p:nvSpPr>
+          <p:cNvPr id="36" name="TextBox 35"/>
+          <p:cNvSpPr txBox="1"/>
+          <p:nvPr/>
+        </p:nvSpPr>
+        <p:spPr>
+          <a:xfrm>
+            <a:off x="5303520" y="2880360"/>
+            <a:ext cx="1554480" cy="274320"/>
+          </a:xfrm>
+          <a:prstGeom prst="rect">
+            <a:avLst/>
+          </a:prstGeom>
+          <a:noFill/>
+        </p:spPr>
+        <p:txBody>
+          <a:bodyPr wrap="square">
+            <a:spAutoFit/>
+          </a:bodyPr>
+          <a:lstStyle/>
+          <a:p>
+            <a:pPr algn="l">
+              <a:defRPr sz="1000" b="0">
+                <a:solidFill>
+                  <a:srgbClr val="4A5568"/>
+                </a:solidFill>
+                <a:latin typeface="Trebuchet MS"/>
+              </a:defRPr>
+            </a:pPr>
+            <a:r>
+              <a:t>Secure multi-agent</a:t>
+            </a:r>
+          </a:p>
+        </p:txBody>
+      </p:sp>
+      <p:sp>
+        <p:nvSpPr>
+          <p:cNvPr id="37" name="TextBox 36"/>
+          <p:cNvSpPr txBox="1"/>
+          <p:nvPr/>
+        </p:nvSpPr>
+        <p:spPr>
+          <a:xfrm>
+            <a:off x="5303520" y="2880360"/>
+            <a:ext cx="3200400" cy="274320"/>
+          </a:xfrm>
+          <a:prstGeom prst="rect">
+            <a:avLst/>
+          </a:prstGeom>
+          <a:noFill/>
+        </p:spPr>
+        <p:txBody>
+          <a:bodyPr wrap="square">
+            <a:spAutoFit/>
+          </a:bodyPr>
+          <a:lstStyle/>
+          <a:p>
+            <a:pPr algn="l">
+              <a:defRPr sz="1000" b="0">
+                <a:solidFill>
+                  <a:srgbClr val="4A5568"/>
+                </a:solidFill>
+                <a:latin typeface="Trebuchet MS"/>
+              </a:defRPr>
+            </a:pPr>
+            <a:r>
+              <a:t>Secure multi-agent harnesses</a:t>
+            </a:r>
+          </a:p>
+        </p:txBody>
+      </p:sp>
+      <p:sp>
+        <p:nvSpPr>
+          <p:cNvPr id="38" name="TextBox 37"/>
+          <p:cNvSpPr txBox="1"/>
+          <p:nvPr/>
+        </p:nvSpPr>
+        <p:spPr>
+          <a:xfrm>
+            <a:off x="502920" y="3474720"/>
+            <a:ext cx="8229600" cy="1097280"/>
+          </a:xfrm>
+          <a:prstGeom prst="rect">
+            <a:avLst/>
+          </a:prstGeom>
+          <a:noFill/>
+        </p:spPr>
+        <p:txBody>
+          <a:bodyPr wrap="square">
+            <a:spAutoFit/>
+          </a:bodyPr>
+          <a:lstStyle/>
+          <a:p>
+            <a:pPr algn="l">
+              <a:spcAft>
+                <a:spcPts val="200"/>
+              </a:spcAft>
+              <a:defRPr sz="1200" b="1">
+                <a:solidFill>
+                  <a:srgbClr val="1B2A4A"/>
+                </a:solidFill>
+                <a:latin typeface="Trebuchet MS"/>
+              </a:defRPr>
+            </a:pPr>
+            <a:r>
+              <a:t>Each phase catches different bugs.  Together they cover the full lifecycle.</a:t>
+            </a:r>
+          </a:p>
+          <a:p>
+            <a:pPr algn="l">
+              <a:spcAft>
+                <a:spcPts val="200"/>
               </a:spcAft>
               <a:defRPr sz="1100" b="0">
                 <a:solidFill>
-                  <a:srgbClr val="1B2A4A"/>
-                </a:solidFill>
-                <a:latin typeface="Trebuchet MS"/>
-              </a:defRPr>
-            </a:pPr>
-            <a:r>
-              <a:t>Hoare triples      VCG + Z3          Static analysis    DFA monitors       Trace verification</a:t>
-            </a:r>
-          </a:p>
-          <a:p>
-            <a:pPr algn="l">
-              <a:spcAft>
-                <a:spcPts val="300"/>
-              </a:spcAft>
-              <a:defRPr sz="1100" b="0">
-                <a:solidFill>
-                  <a:srgbClr val="4A5568"/>
-                </a:solidFill>
-                <a:latin typeface="Courier New"/>
-              </a:defRPr>
-            </a:pPr>
-            <a:r>
-              <a:t>{P} C {Q}          wp()              Datalog            ALLOW/DENY         safety/liveness</a:t>
-            </a:r>
-          </a:p>
-          <a:p>
-            <a:pPr algn="l">
-              <a:spcAft>
-                <a:spcPts val="300"/>
-              </a:spcAft>
-              <a:defRPr sz="1000" b="0">
-                <a:solidFill>
-                  <a:srgbClr val="8A95A7"/>
-                </a:solidFill>
-                <a:latin typeface="Trebuchet MS"/>
-              </a:defRPr>
-            </a:pPr>
-            <a:r>
-              <a:t>Lec 5–6            Lec 6–7           Lec 8–9            Lec 10             Lec 10</a:t>
-            </a:r>
-          </a:p>
-          <a:p>
-            <a:pPr algn="l">
-              <a:spcAft>
-                <a:spcPts val="300"/>
-              </a:spcAft>
-              <a:defRPr sz="1000" b="0">
-                <a:solidFill>
-                  <a:srgbClr val="4A5568"/>
-                </a:solidFill>
-                <a:latin typeface="Trebuchet MS"/>
-              </a:defRPr>
-            </a:pPr>
-          </a:p>
-          <a:p>
-            <a:pPr algn="l">
-              <a:spcAft>
-                <a:spcPts val="300"/>
-              </a:spcAft>
-              <a:defRPr sz="1100" b="1">
-                <a:solidFill>
-                  <a:srgbClr val="E67E22"/>
-                </a:solidFill>
-                <a:latin typeface="Trebuchet MS"/>
-              </a:defRPr>
-            </a:pPr>
-            <a:r>
-              <a:t>      HW1                HW2                  HW3                              HW4</a:t>
-            </a:r>
-          </a:p>
-          <a:p>
-            <a:pPr algn="l">
-              <a:spcAft>
-                <a:spcPts val="300"/>
-              </a:spcAft>
-              <a:defRPr sz="1100" b="0">
-                <a:solidFill>
-                  <a:srgbClr val="4A5568"/>
-                </a:solidFill>
-                <a:latin typeface="Trebuchet MS"/>
-              </a:defRPr>
-            </a:pPr>
-            <a:r>
-              <a:t>   Build a skill      Verify programs      Audit skills        →  Secure multi-agent harnesses</a:t>
+                  <a:srgbClr val="4A5568"/>
+                </a:solidFill>
+                <a:latin typeface="Trebuchet MS"/>
+              </a:defRPr>
+            </a:pPr>
+            <a:r>
+              <a:t>No single technique is sufficient — that’s why you learned all five.</a:t>
             </a:r>
           </a:p>
         </p:txBody>

</xml_diff>

<commit_message>
Update lecture 17 slides
Co-Authored-By: Claude Opus 4.6 (1M context) <noreply@anthropic.com>
</commit_message>
<xml_diff>
--- a/lectures/lecture17_full_picture.pptx
+++ b/lectures/lecture17_full_picture.pptx
@@ -5,30 +5,30 @@
     <p:sldMasterId id="2147483648" r:id="rId1"/>
   </p:sldMasterIdLst>
   <p:sldIdLst>
-    <p:sldId id="256" r:id="rId7"/>
-    <p:sldId id="257" r:id="rId8"/>
-    <p:sldId id="258" r:id="rId9"/>
-    <p:sldId id="259" r:id="rId10"/>
-    <p:sldId id="260" r:id="rId11"/>
-    <p:sldId id="261" r:id="rId12"/>
-    <p:sldId id="262" r:id="rId13"/>
-    <p:sldId id="263" r:id="rId14"/>
-    <p:sldId id="264" r:id="rId15"/>
-    <p:sldId id="265" r:id="rId16"/>
-    <p:sldId id="266" r:id="rId17"/>
-    <p:sldId id="267" r:id="rId18"/>
-    <p:sldId id="268" r:id="rId19"/>
-    <p:sldId id="269" r:id="rId20"/>
-    <p:sldId id="270" r:id="rId21"/>
-    <p:sldId id="271" r:id="rId22"/>
-    <p:sldId id="272" r:id="rId23"/>
-    <p:sldId id="273" r:id="rId24"/>
-    <p:sldId id="274" r:id="rId25"/>
-    <p:sldId id="275" r:id="rId26"/>
-    <p:sldId id="276" r:id="rId27"/>
-    <p:sldId id="277" r:id="rId28"/>
+    <p:sldId id="256" r:id="rId2"/>
+    <p:sldId id="257" r:id="rId3"/>
+    <p:sldId id="258" r:id="rId4"/>
+    <p:sldId id="259" r:id="rId5"/>
+    <p:sldId id="260" r:id="rId6"/>
+    <p:sldId id="261" r:id="rId7"/>
+    <p:sldId id="262" r:id="rId8"/>
+    <p:sldId id="263" r:id="rId9"/>
+    <p:sldId id="264" r:id="rId10"/>
+    <p:sldId id="265" r:id="rId11"/>
+    <p:sldId id="266" r:id="rId12"/>
+    <p:sldId id="267" r:id="rId13"/>
+    <p:sldId id="268" r:id="rId14"/>
+    <p:sldId id="269" r:id="rId15"/>
+    <p:sldId id="270" r:id="rId16"/>
+    <p:sldId id="271" r:id="rId17"/>
+    <p:sldId id="272" r:id="rId18"/>
+    <p:sldId id="273" r:id="rId19"/>
+    <p:sldId id="274" r:id="rId20"/>
+    <p:sldId id="275" r:id="rId21"/>
+    <p:sldId id="276" r:id="rId22"/>
+    <p:sldId id="277" r:id="rId23"/>
   </p:sldIdLst>
-  <p:sldSz cx="9144000" cy="5143500" type="screen4x3"/>
+  <p:sldSz cx="9144000" cy="5143500" type="screen16x9"/>
   <p:notesSz cx="6858000" cy="9144000"/>
   <p:defaultTextStyle>
     <a:defPPr>
@@ -125,6 +125,22 @@
       </a:defRPr>
     </a:lvl9pPr>
   </p:defaultTextStyle>
+  <p:extLst>
+    <p:ext uri="{EFAFB233-063F-42B5-8137-9DF3F51BA10A}">
+      <p15:sldGuideLst xmlns:p15="http://schemas.microsoft.com/office/powerpoint/2012/main">
+        <p15:guide id="1" orient="horz" pos="2160">
+          <p15:clr>
+            <a:srgbClr val="A4A3A4"/>
+          </p15:clr>
+        </p15:guide>
+        <p15:guide id="2" pos="2880">
+          <p15:clr>
+            <a:srgbClr val="A4A3A4"/>
+          </p15:clr>
+        </p15:guide>
+      </p15:sldGuideLst>
+    </p:ext>
+  </p:extLst>
 </p:presentation>
 </file>
 
@@ -166,10 +182,9 @@
           <a:lstStyle/>
           <a:p>
             <a:r>
-              <a:rPr lang="en-US" smtClean="0"/>
+              <a:rPr lang="en-US"/>
               <a:t>Click to edit Master title style</a:t>
             </a:r>
-            <a:endParaRPr lang="en-US"/>
           </a:p>
         </p:txBody>
       </p:sp>
@@ -285,10 +300,9 @@
           </a:lstStyle>
           <a:p>
             <a:r>
-              <a:rPr lang="en-US" smtClean="0"/>
+              <a:rPr lang="en-US"/>
               <a:t>Click to edit Master subtitle style</a:t>
             </a:r>
-            <a:endParaRPr lang="en-US"/>
           </a:p>
         </p:txBody>
       </p:sp>
@@ -309,7 +323,7 @@
           <a:p>
             <a:fld id="{5BCAD085-E8A6-8845-BD4E-CB4CCA059FC4}" type="datetimeFigureOut">
               <a:rPr lang="en-US" smtClean="0"/>
-              <a:t>1/27/13</a:t>
+              <a:t>5/24/26</a:t>
             </a:fld>
             <a:endParaRPr lang="en-US"/>
           </a:p>
@@ -403,10 +417,9 @@
           <a:lstStyle/>
           <a:p>
             <a:r>
-              <a:rPr lang="en-US" smtClean="0"/>
+              <a:rPr lang="en-US"/>
               <a:t>Click to edit Master title style</a:t>
             </a:r>
-            <a:endParaRPr lang="en-US"/>
           </a:p>
         </p:txBody>
       </p:sp>
@@ -427,38 +440,37 @@
           <a:p>
             <a:pPr lvl="0"/>
             <a:r>
-              <a:rPr lang="en-US" smtClean="0"/>
+              <a:rPr lang="en-US"/>
               <a:t>Click to edit Master text styles</a:t>
             </a:r>
           </a:p>
           <a:p>
             <a:pPr lvl="1"/>
             <a:r>
-              <a:rPr lang="en-US" smtClean="0"/>
+              <a:rPr lang="en-US"/>
               <a:t>Second level</a:t>
             </a:r>
           </a:p>
           <a:p>
             <a:pPr lvl="2"/>
             <a:r>
-              <a:rPr lang="en-US" smtClean="0"/>
+              <a:rPr lang="en-US"/>
               <a:t>Third level</a:t>
             </a:r>
           </a:p>
           <a:p>
             <a:pPr lvl="3"/>
             <a:r>
-              <a:rPr lang="en-US" smtClean="0"/>
+              <a:rPr lang="en-US"/>
               <a:t>Fourth level</a:t>
             </a:r>
           </a:p>
           <a:p>
             <a:pPr lvl="4"/>
             <a:r>
-              <a:rPr lang="en-US" smtClean="0"/>
+              <a:rPr lang="en-US"/>
               <a:t>Fifth level</a:t>
             </a:r>
-            <a:endParaRPr lang="en-US"/>
           </a:p>
         </p:txBody>
       </p:sp>
@@ -479,7 +491,7 @@
           <a:p>
             <a:fld id="{5BCAD085-E8A6-8845-BD4E-CB4CCA059FC4}" type="datetimeFigureOut">
               <a:rPr lang="en-US" smtClean="0"/>
-              <a:t>1/27/13</a:t>
+              <a:t>5/24/26</a:t>
             </a:fld>
             <a:endParaRPr lang="en-US"/>
           </a:p>
@@ -578,10 +590,9 @@
           <a:lstStyle/>
           <a:p>
             <a:r>
-              <a:rPr lang="en-US" smtClean="0"/>
+              <a:rPr lang="en-US"/>
               <a:t>Click to edit Master title style</a:t>
             </a:r>
-            <a:endParaRPr lang="en-US"/>
           </a:p>
         </p:txBody>
       </p:sp>
@@ -607,38 +618,37 @@
           <a:p>
             <a:pPr lvl="0"/>
             <a:r>
-              <a:rPr lang="en-US" smtClean="0"/>
+              <a:rPr lang="en-US"/>
               <a:t>Click to edit Master text styles</a:t>
             </a:r>
           </a:p>
           <a:p>
             <a:pPr lvl="1"/>
             <a:r>
-              <a:rPr lang="en-US" smtClean="0"/>
+              <a:rPr lang="en-US"/>
               <a:t>Second level</a:t>
             </a:r>
           </a:p>
           <a:p>
             <a:pPr lvl="2"/>
             <a:r>
-              <a:rPr lang="en-US" smtClean="0"/>
+              <a:rPr lang="en-US"/>
               <a:t>Third level</a:t>
             </a:r>
           </a:p>
           <a:p>
             <a:pPr lvl="3"/>
             <a:r>
-              <a:rPr lang="en-US" smtClean="0"/>
+              <a:rPr lang="en-US"/>
               <a:t>Fourth level</a:t>
             </a:r>
           </a:p>
           <a:p>
             <a:pPr lvl="4"/>
             <a:r>
-              <a:rPr lang="en-US" smtClean="0"/>
+              <a:rPr lang="en-US"/>
               <a:t>Fifth level</a:t>
             </a:r>
-            <a:endParaRPr lang="en-US"/>
           </a:p>
         </p:txBody>
       </p:sp>
@@ -659,7 +669,7 @@
           <a:p>
             <a:fld id="{5BCAD085-E8A6-8845-BD4E-CB4CCA059FC4}" type="datetimeFigureOut">
               <a:rPr lang="en-US" smtClean="0"/>
-              <a:t>1/27/13</a:t>
+              <a:t>5/24/26</a:t>
             </a:fld>
             <a:endParaRPr lang="en-US"/>
           </a:p>
@@ -753,10 +763,9 @@
           <a:lstStyle/>
           <a:p>
             <a:r>
-              <a:rPr lang="en-US" smtClean="0"/>
+              <a:rPr lang="en-US"/>
               <a:t>Click to edit Master title style</a:t>
             </a:r>
-            <a:endParaRPr lang="en-US"/>
           </a:p>
         </p:txBody>
       </p:sp>
@@ -777,38 +786,37 @@
           <a:p>
             <a:pPr lvl="0"/>
             <a:r>
-              <a:rPr lang="en-US" smtClean="0"/>
+              <a:rPr lang="en-US"/>
               <a:t>Click to edit Master text styles</a:t>
             </a:r>
           </a:p>
           <a:p>
             <a:pPr lvl="1"/>
             <a:r>
-              <a:rPr lang="en-US" smtClean="0"/>
+              <a:rPr lang="en-US"/>
               <a:t>Second level</a:t>
             </a:r>
           </a:p>
           <a:p>
             <a:pPr lvl="2"/>
             <a:r>
-              <a:rPr lang="en-US" smtClean="0"/>
+              <a:rPr lang="en-US"/>
               <a:t>Third level</a:t>
             </a:r>
           </a:p>
           <a:p>
             <a:pPr lvl="3"/>
             <a:r>
-              <a:rPr lang="en-US" smtClean="0"/>
+              <a:rPr lang="en-US"/>
               <a:t>Fourth level</a:t>
             </a:r>
           </a:p>
           <a:p>
             <a:pPr lvl="4"/>
             <a:r>
-              <a:rPr lang="en-US" smtClean="0"/>
+              <a:rPr lang="en-US"/>
               <a:t>Fifth level</a:t>
             </a:r>
-            <a:endParaRPr lang="en-US"/>
           </a:p>
         </p:txBody>
       </p:sp>
@@ -829,7 +837,7 @@
           <a:p>
             <a:fld id="{5BCAD085-E8A6-8845-BD4E-CB4CCA059FC4}" type="datetimeFigureOut">
               <a:rPr lang="en-US" smtClean="0"/>
-              <a:t>1/27/13</a:t>
+              <a:t>5/24/26</a:t>
             </a:fld>
             <a:endParaRPr lang="en-US"/>
           </a:p>
@@ -932,10 +940,9 @@
           </a:lstStyle>
           <a:p>
             <a:r>
-              <a:rPr lang="en-US" smtClean="0"/>
+              <a:rPr lang="en-US"/>
               <a:t>Click to edit Master title style</a:t>
             </a:r>
-            <a:endParaRPr lang="en-US"/>
           </a:p>
         </p:txBody>
       </p:sp>
@@ -1052,7 +1059,7 @@
           <a:p>
             <a:pPr lvl="0"/>
             <a:r>
-              <a:rPr lang="en-US" smtClean="0"/>
+              <a:rPr lang="en-US"/>
               <a:t>Click to edit Master text styles</a:t>
             </a:r>
           </a:p>
@@ -1075,7 +1082,7 @@
           <a:p>
             <a:fld id="{5BCAD085-E8A6-8845-BD4E-CB4CCA059FC4}" type="datetimeFigureOut">
               <a:rPr lang="en-US" smtClean="0"/>
-              <a:t>1/27/13</a:t>
+              <a:t>5/24/26</a:t>
             </a:fld>
             <a:endParaRPr lang="en-US"/>
           </a:p>
@@ -1169,10 +1176,9 @@
           <a:lstStyle/>
           <a:p>
             <a:r>
-              <a:rPr lang="en-US" smtClean="0"/>
+              <a:rPr lang="en-US"/>
               <a:t>Click to edit Master title style</a:t>
             </a:r>
-            <a:endParaRPr lang="en-US"/>
           </a:p>
         </p:txBody>
       </p:sp>
@@ -1226,38 +1232,37 @@
           <a:p>
             <a:pPr lvl="0"/>
             <a:r>
-              <a:rPr lang="en-US" smtClean="0"/>
+              <a:rPr lang="en-US"/>
               <a:t>Click to edit Master text styles</a:t>
             </a:r>
           </a:p>
           <a:p>
             <a:pPr lvl="1"/>
             <a:r>
-              <a:rPr lang="en-US" smtClean="0"/>
+              <a:rPr lang="en-US"/>
               <a:t>Second level</a:t>
             </a:r>
           </a:p>
           <a:p>
             <a:pPr lvl="2"/>
             <a:r>
-              <a:rPr lang="en-US" smtClean="0"/>
+              <a:rPr lang="en-US"/>
               <a:t>Third level</a:t>
             </a:r>
           </a:p>
           <a:p>
             <a:pPr lvl="3"/>
             <a:r>
-              <a:rPr lang="en-US" smtClean="0"/>
+              <a:rPr lang="en-US"/>
               <a:t>Fourth level</a:t>
             </a:r>
           </a:p>
           <a:p>
             <a:pPr lvl="4"/>
             <a:r>
-              <a:rPr lang="en-US" smtClean="0"/>
+              <a:rPr lang="en-US"/>
               <a:t>Fifth level</a:t>
             </a:r>
-            <a:endParaRPr lang="en-US"/>
           </a:p>
         </p:txBody>
       </p:sp>
@@ -1311,38 +1316,37 @@
           <a:p>
             <a:pPr lvl="0"/>
             <a:r>
-              <a:rPr lang="en-US" smtClean="0"/>
+              <a:rPr lang="en-US"/>
               <a:t>Click to edit Master text styles</a:t>
             </a:r>
           </a:p>
           <a:p>
             <a:pPr lvl="1"/>
             <a:r>
-              <a:rPr lang="en-US" smtClean="0"/>
+              <a:rPr lang="en-US"/>
               <a:t>Second level</a:t>
             </a:r>
           </a:p>
           <a:p>
             <a:pPr lvl="2"/>
             <a:r>
-              <a:rPr lang="en-US" smtClean="0"/>
+              <a:rPr lang="en-US"/>
               <a:t>Third level</a:t>
             </a:r>
           </a:p>
           <a:p>
             <a:pPr lvl="3"/>
             <a:r>
-              <a:rPr lang="en-US" smtClean="0"/>
+              <a:rPr lang="en-US"/>
               <a:t>Fourth level</a:t>
             </a:r>
           </a:p>
           <a:p>
             <a:pPr lvl="4"/>
             <a:r>
-              <a:rPr lang="en-US" smtClean="0"/>
+              <a:rPr lang="en-US"/>
               <a:t>Fifth level</a:t>
             </a:r>
-            <a:endParaRPr lang="en-US"/>
           </a:p>
         </p:txBody>
       </p:sp>
@@ -1363,7 +1367,7 @@
           <a:p>
             <a:fld id="{5BCAD085-E8A6-8845-BD4E-CB4CCA059FC4}" type="datetimeFigureOut">
               <a:rPr lang="en-US" smtClean="0"/>
-              <a:t>1/27/13</a:t>
+              <a:t>5/24/26</a:t>
             </a:fld>
             <a:endParaRPr lang="en-US"/>
           </a:p>
@@ -1461,10 +1465,9 @@
           </a:lstStyle>
           <a:p>
             <a:r>
-              <a:rPr lang="en-US" smtClean="0"/>
+              <a:rPr lang="en-US"/>
               <a:t>Click to edit Master title style</a:t>
             </a:r>
-            <a:endParaRPr lang="en-US"/>
           </a:p>
         </p:txBody>
       </p:sp>
@@ -1527,7 +1530,7 @@
           <a:p>
             <a:pPr lvl="0"/>
             <a:r>
-              <a:rPr lang="en-US" smtClean="0"/>
+              <a:rPr lang="en-US"/>
               <a:t>Click to edit Master text styles</a:t>
             </a:r>
           </a:p>
@@ -1583,38 +1586,37 @@
           <a:p>
             <a:pPr lvl="0"/>
             <a:r>
-              <a:rPr lang="en-US" smtClean="0"/>
+              <a:rPr lang="en-US"/>
               <a:t>Click to edit Master text styles</a:t>
             </a:r>
           </a:p>
           <a:p>
             <a:pPr lvl="1"/>
             <a:r>
-              <a:rPr lang="en-US" smtClean="0"/>
+              <a:rPr lang="en-US"/>
               <a:t>Second level</a:t>
             </a:r>
           </a:p>
           <a:p>
             <a:pPr lvl="2"/>
             <a:r>
-              <a:rPr lang="en-US" smtClean="0"/>
+              <a:rPr lang="en-US"/>
               <a:t>Third level</a:t>
             </a:r>
           </a:p>
           <a:p>
             <a:pPr lvl="3"/>
             <a:r>
-              <a:rPr lang="en-US" smtClean="0"/>
+              <a:rPr lang="en-US"/>
               <a:t>Fourth level</a:t>
             </a:r>
           </a:p>
           <a:p>
             <a:pPr lvl="4"/>
             <a:r>
-              <a:rPr lang="en-US" smtClean="0"/>
+              <a:rPr lang="en-US"/>
               <a:t>Fifth level</a:t>
             </a:r>
-            <a:endParaRPr lang="en-US"/>
           </a:p>
         </p:txBody>
       </p:sp>
@@ -1677,7 +1679,7 @@
           <a:p>
             <a:pPr lvl="0"/>
             <a:r>
-              <a:rPr lang="en-US" smtClean="0"/>
+              <a:rPr lang="en-US"/>
               <a:t>Click to edit Master text styles</a:t>
             </a:r>
           </a:p>
@@ -1733,38 +1735,37 @@
           <a:p>
             <a:pPr lvl="0"/>
             <a:r>
-              <a:rPr lang="en-US" smtClean="0"/>
+              <a:rPr lang="en-US"/>
               <a:t>Click to edit Master text styles</a:t>
             </a:r>
           </a:p>
           <a:p>
             <a:pPr lvl="1"/>
             <a:r>
-              <a:rPr lang="en-US" smtClean="0"/>
+              <a:rPr lang="en-US"/>
               <a:t>Second level</a:t>
             </a:r>
           </a:p>
           <a:p>
             <a:pPr lvl="2"/>
             <a:r>
-              <a:rPr lang="en-US" smtClean="0"/>
+              <a:rPr lang="en-US"/>
               <a:t>Third level</a:t>
             </a:r>
           </a:p>
           <a:p>
             <a:pPr lvl="3"/>
             <a:r>
-              <a:rPr lang="en-US" smtClean="0"/>
+              <a:rPr lang="en-US"/>
               <a:t>Fourth level</a:t>
             </a:r>
           </a:p>
           <a:p>
             <a:pPr lvl="4"/>
             <a:r>
-              <a:rPr lang="en-US" smtClean="0"/>
+              <a:rPr lang="en-US"/>
               <a:t>Fifth level</a:t>
             </a:r>
-            <a:endParaRPr lang="en-US"/>
           </a:p>
         </p:txBody>
       </p:sp>
@@ -1785,7 +1786,7 @@
           <a:p>
             <a:fld id="{5BCAD085-E8A6-8845-BD4E-CB4CCA059FC4}" type="datetimeFigureOut">
               <a:rPr lang="en-US" smtClean="0"/>
-              <a:t>1/27/13</a:t>
+              <a:t>5/24/26</a:t>
             </a:fld>
             <a:endParaRPr lang="en-US"/>
           </a:p>
@@ -1879,10 +1880,9 @@
           <a:lstStyle/>
           <a:p>
             <a:r>
-              <a:rPr lang="en-US" smtClean="0"/>
+              <a:rPr lang="en-US"/>
               <a:t>Click to edit Master title style</a:t>
             </a:r>
-            <a:endParaRPr lang="en-US"/>
           </a:p>
         </p:txBody>
       </p:sp>
@@ -1903,7 +1903,7 @@
           <a:p>
             <a:fld id="{5BCAD085-E8A6-8845-BD4E-CB4CCA059FC4}" type="datetimeFigureOut">
               <a:rPr lang="en-US" smtClean="0"/>
-              <a:t>1/27/13</a:t>
+              <a:t>5/24/26</a:t>
             </a:fld>
             <a:endParaRPr lang="en-US"/>
           </a:p>
@@ -1998,7 +1998,7 @@
           <a:p>
             <a:fld id="{5BCAD085-E8A6-8845-BD4E-CB4CCA059FC4}" type="datetimeFigureOut">
               <a:rPr lang="en-US" smtClean="0"/>
-              <a:t>1/27/13</a:t>
+              <a:t>5/24/26</a:t>
             </a:fld>
             <a:endParaRPr lang="en-US"/>
           </a:p>
@@ -2101,10 +2101,9 @@
           </a:lstStyle>
           <a:p>
             <a:r>
-              <a:rPr lang="en-US" smtClean="0"/>
+              <a:rPr lang="en-US"/>
               <a:t>Click to edit Master title style</a:t>
             </a:r>
-            <a:endParaRPr lang="en-US"/>
           </a:p>
         </p:txBody>
       </p:sp>
@@ -2158,38 +2157,37 @@
           <a:p>
             <a:pPr lvl="0"/>
             <a:r>
-              <a:rPr lang="en-US" smtClean="0"/>
+              <a:rPr lang="en-US"/>
               <a:t>Click to edit Master text styles</a:t>
             </a:r>
           </a:p>
           <a:p>
             <a:pPr lvl="1"/>
             <a:r>
-              <a:rPr lang="en-US" smtClean="0"/>
+              <a:rPr lang="en-US"/>
               <a:t>Second level</a:t>
             </a:r>
           </a:p>
           <a:p>
             <a:pPr lvl="2"/>
             <a:r>
-              <a:rPr lang="en-US" smtClean="0"/>
+              <a:rPr lang="en-US"/>
               <a:t>Third level</a:t>
             </a:r>
           </a:p>
           <a:p>
             <a:pPr lvl="3"/>
             <a:r>
-              <a:rPr lang="en-US" smtClean="0"/>
+              <a:rPr lang="en-US"/>
               <a:t>Fourth level</a:t>
             </a:r>
           </a:p>
           <a:p>
             <a:pPr lvl="4"/>
             <a:r>
-              <a:rPr lang="en-US" smtClean="0"/>
+              <a:rPr lang="en-US"/>
               <a:t>Fifth level</a:t>
             </a:r>
-            <a:endParaRPr lang="en-US"/>
           </a:p>
         </p:txBody>
       </p:sp>
@@ -2252,7 +2250,7 @@
           <a:p>
             <a:pPr lvl="0"/>
             <a:r>
-              <a:rPr lang="en-US" smtClean="0"/>
+              <a:rPr lang="en-US"/>
               <a:t>Click to edit Master text styles</a:t>
             </a:r>
           </a:p>
@@ -2275,7 +2273,7 @@
           <a:p>
             <a:fld id="{5BCAD085-E8A6-8845-BD4E-CB4CCA059FC4}" type="datetimeFigureOut">
               <a:rPr lang="en-US" smtClean="0"/>
-              <a:t>1/27/13</a:t>
+              <a:t>5/24/26</a:t>
             </a:fld>
             <a:endParaRPr lang="en-US"/>
           </a:p>
@@ -2378,10 +2376,9 @@
           </a:lstStyle>
           <a:p>
             <a:r>
-              <a:rPr lang="en-US" smtClean="0"/>
+              <a:rPr lang="en-US"/>
               <a:t>Click to edit Master title style</a:t>
             </a:r>
-            <a:endParaRPr lang="en-US"/>
           </a:p>
         </p:txBody>
       </p:sp>
@@ -2505,7 +2502,7 @@
           <a:p>
             <a:pPr lvl="0"/>
             <a:r>
-              <a:rPr lang="en-US" smtClean="0"/>
+              <a:rPr lang="en-US"/>
               <a:t>Click to edit Master text styles</a:t>
             </a:r>
           </a:p>
@@ -2528,7 +2525,7 @@
           <a:p>
             <a:fld id="{5BCAD085-E8A6-8845-BD4E-CB4CCA059FC4}" type="datetimeFigureOut">
               <a:rPr lang="en-US" smtClean="0"/>
-              <a:t>1/27/13</a:t>
+              <a:t>5/24/26</a:t>
             </a:fld>
             <a:endParaRPr lang="en-US"/>
           </a:p>
@@ -2637,10 +2634,9 @@
           <a:lstStyle/>
           <a:p>
             <a:r>
-              <a:rPr lang="en-US" smtClean="0"/>
+              <a:rPr lang="en-US"/>
               <a:t>Click to edit Master title style</a:t>
             </a:r>
-            <a:endParaRPr lang="en-US"/>
           </a:p>
         </p:txBody>
       </p:sp>
@@ -2671,38 +2667,37 @@
           <a:p>
             <a:pPr lvl="0"/>
             <a:r>
-              <a:rPr lang="en-US" smtClean="0"/>
+              <a:rPr lang="en-US"/>
               <a:t>Click to edit Master text styles</a:t>
             </a:r>
           </a:p>
           <a:p>
             <a:pPr lvl="1"/>
             <a:r>
-              <a:rPr lang="en-US" smtClean="0"/>
+              <a:rPr lang="en-US"/>
               <a:t>Second level</a:t>
             </a:r>
           </a:p>
           <a:p>
             <a:pPr lvl="2"/>
             <a:r>
-              <a:rPr lang="en-US" smtClean="0"/>
+              <a:rPr lang="en-US"/>
               <a:t>Third level</a:t>
             </a:r>
           </a:p>
           <a:p>
             <a:pPr lvl="3"/>
             <a:r>
-              <a:rPr lang="en-US" smtClean="0"/>
+              <a:rPr lang="en-US"/>
               <a:t>Fourth level</a:t>
             </a:r>
           </a:p>
           <a:p>
             <a:pPr lvl="4"/>
             <a:r>
-              <a:rPr lang="en-US" smtClean="0"/>
+              <a:rPr lang="en-US"/>
               <a:t>Fifth level</a:t>
             </a:r>
-            <a:endParaRPr lang="en-US"/>
           </a:p>
         </p:txBody>
       </p:sp>
@@ -2741,7 +2736,7 @@
           <a:p>
             <a:fld id="{5BCAD085-E8A6-8845-BD4E-CB4CCA059FC4}" type="datetimeFigureOut">
               <a:rPr lang="en-US" smtClean="0"/>
-              <a:t>1/27/13</a:t>
+              <a:t>5/24/26</a:t>
             </a:fld>
             <a:endParaRPr lang="en-US"/>
           </a:p>
@@ -3100,7 +3095,7 @@
 </file>
 
 <file path=ppt/slides/slide1.xml><?xml version="1.0" encoding="utf-8"?>
-<p:sld xmlns:a="http://schemas.openxmlformats.org/drawingml/2006/main" xmlns:p="http://schemas.openxmlformats.org/presentationml/2006/main" xmlns:r="http://schemas.openxmlformats.org/officeDocument/2006/relationships">
+<p:sld xmlns:a="http://schemas.openxmlformats.org/drawingml/2006/main" xmlns:r="http://schemas.openxmlformats.org/officeDocument/2006/relationships" xmlns:p="http://schemas.openxmlformats.org/presentationml/2006/main">
   <p:cSld>
     <p:bg>
       <p:bgPr>
@@ -3116,7 +3111,14 @@
         <p:cNvGrpSpPr/>
         <p:nvPr/>
       </p:nvGrpSpPr>
-      <p:grpSpPr/>
+      <p:grpSpPr>
+        <a:xfrm>
+          <a:off x="0" y="0"/>
+          <a:ext cx="0" cy="0"/>
+          <a:chOff x="0" y="0"/>
+          <a:chExt cx="0" cy="0"/>
+        </a:xfrm>
+      </p:grpSpPr>
       <p:sp>
         <p:nvSpPr>
           <p:cNvPr id="2" name="TextBox 1"/>
@@ -3342,7 +3344,7 @@
 </file>
 
 <file path=ppt/slides/slide10.xml><?xml version="1.0" encoding="utf-8"?>
-<p:sld xmlns:a="http://schemas.openxmlformats.org/drawingml/2006/main" xmlns:p="http://schemas.openxmlformats.org/presentationml/2006/main" xmlns:r="http://schemas.openxmlformats.org/officeDocument/2006/relationships">
+<p:sld xmlns:a="http://schemas.openxmlformats.org/drawingml/2006/main" xmlns:r="http://schemas.openxmlformats.org/officeDocument/2006/relationships" xmlns:p="http://schemas.openxmlformats.org/presentationml/2006/main">
   <p:cSld>
     <p:spTree>
       <p:nvGrpSpPr>
@@ -3350,7 +3352,14 @@
         <p:cNvGrpSpPr/>
         <p:nvPr/>
       </p:nvGrpSpPr>
-      <p:grpSpPr/>
+      <p:grpSpPr>
+        <a:xfrm>
+          <a:off x="0" y="0"/>
+          <a:ext cx="0" cy="0"/>
+          <a:chOff x="0" y="0"/>
+          <a:chExt cx="0" cy="0"/>
+        </a:xfrm>
+      </p:grpSpPr>
       <p:sp>
         <p:nvSpPr>
           <p:cNvPr id="2" name="TextBox 1"/>
@@ -3576,6 +3585,7 @@
                 <a:latin typeface="Trebuchet MS"/>
               </a:defRPr>
             </a:pPr>
+            <a:endParaRPr/>
           </a:p>
           <a:p>
             <a:pPr algn="l">
@@ -3653,6 +3663,7 @@
                 <a:latin typeface="Trebuchet MS"/>
               </a:defRPr>
             </a:pPr>
+            <a:endParaRPr/>
           </a:p>
           <a:p>
             <a:pPr algn="l">
@@ -3714,6 +3725,7 @@
                 <a:latin typeface="Trebuchet MS"/>
               </a:defRPr>
             </a:pPr>
+            <a:endParaRPr/>
           </a:p>
           <a:p>
             <a:pPr algn="l">
@@ -3742,7 +3754,7 @@
 </file>
 
 <file path=ppt/slides/slide11.xml><?xml version="1.0" encoding="utf-8"?>
-<p:sld xmlns:a="http://schemas.openxmlformats.org/drawingml/2006/main" xmlns:p="http://schemas.openxmlformats.org/presentationml/2006/main" xmlns:r="http://schemas.openxmlformats.org/officeDocument/2006/relationships">
+<p:sld xmlns:a="http://schemas.openxmlformats.org/drawingml/2006/main" xmlns:r="http://schemas.openxmlformats.org/officeDocument/2006/relationships" xmlns:p="http://schemas.openxmlformats.org/presentationml/2006/main">
   <p:cSld>
     <p:spTree>
       <p:nvGrpSpPr>
@@ -3750,7 +3762,14 @@
         <p:cNvGrpSpPr/>
         <p:nvPr/>
       </p:nvGrpSpPr>
-      <p:grpSpPr/>
+      <p:grpSpPr>
+        <a:xfrm>
+          <a:off x="0" y="0"/>
+          <a:ext cx="0" cy="0"/>
+          <a:chOff x="0" y="0"/>
+          <a:chExt cx="0" cy="0"/>
+        </a:xfrm>
+      </p:grpSpPr>
       <p:sp>
         <p:nvSpPr>
           <p:cNvPr id="2" name="TextBox 1"/>
@@ -3976,6 +3995,7 @@
                 <a:latin typeface="Trebuchet MS"/>
               </a:defRPr>
             </a:pPr>
+            <a:endParaRPr/>
           </a:p>
           <a:p>
             <a:pPr algn="l">
@@ -4053,6 +4073,7 @@
                 <a:latin typeface="Trebuchet MS"/>
               </a:defRPr>
             </a:pPr>
+            <a:endParaRPr/>
           </a:p>
           <a:p>
             <a:pPr algn="l">
@@ -4114,6 +4135,7 @@
                 <a:latin typeface="Trebuchet MS"/>
               </a:defRPr>
             </a:pPr>
+            <a:endParaRPr/>
           </a:p>
           <a:p>
             <a:pPr algn="l">
@@ -4142,7 +4164,7 @@
 </file>
 
 <file path=ppt/slides/slide12.xml><?xml version="1.0" encoding="utf-8"?>
-<p:sld xmlns:a="http://schemas.openxmlformats.org/drawingml/2006/main" xmlns:p="http://schemas.openxmlformats.org/presentationml/2006/main" xmlns:r="http://schemas.openxmlformats.org/officeDocument/2006/relationships">
+<p:sld xmlns:a="http://schemas.openxmlformats.org/drawingml/2006/main" xmlns:r="http://schemas.openxmlformats.org/officeDocument/2006/relationships" xmlns:p="http://schemas.openxmlformats.org/presentationml/2006/main">
   <p:cSld>
     <p:bg>
       <p:bgPr>
@@ -4158,7 +4180,14 @@
         <p:cNvGrpSpPr/>
         <p:nvPr/>
       </p:nvGrpSpPr>
-      <p:grpSpPr/>
+      <p:grpSpPr>
+        <a:xfrm>
+          <a:off x="0" y="0"/>
+          <a:ext cx="0" cy="0"/>
+          <a:chOff x="0" y="0"/>
+          <a:chExt cx="0" cy="0"/>
+        </a:xfrm>
+      </p:grpSpPr>
       <p:sp>
         <p:nvSpPr>
           <p:cNvPr id="2" name="TextBox 1"/>
@@ -4240,7 +4269,7 @@
 </file>
 
 <file path=ppt/slides/slide13.xml><?xml version="1.0" encoding="utf-8"?>
-<p:sld xmlns:a="http://schemas.openxmlformats.org/drawingml/2006/main" xmlns:p="http://schemas.openxmlformats.org/presentationml/2006/main" xmlns:r="http://schemas.openxmlformats.org/officeDocument/2006/relationships">
+<p:sld xmlns:a="http://schemas.openxmlformats.org/drawingml/2006/main" xmlns:r="http://schemas.openxmlformats.org/officeDocument/2006/relationships" xmlns:p="http://schemas.openxmlformats.org/presentationml/2006/main">
   <p:cSld>
     <p:spTree>
       <p:nvGrpSpPr>
@@ -4248,7 +4277,14 @@
         <p:cNvGrpSpPr/>
         <p:nvPr/>
       </p:nvGrpSpPr>
-      <p:grpSpPr/>
+      <p:grpSpPr>
+        <a:xfrm>
+          <a:off x="0" y="0"/>
+          <a:ext cx="0" cy="0"/>
+          <a:chOff x="0" y="0"/>
+          <a:chExt cx="0" cy="0"/>
+        </a:xfrm>
+      </p:grpSpPr>
       <p:sp>
         <p:nvSpPr>
           <p:cNvPr id="2" name="TextBox 1"/>
@@ -4474,6 +4510,7 @@
                 <a:latin typeface="Trebuchet MS"/>
               </a:defRPr>
             </a:pPr>
+            <a:endParaRPr/>
           </a:p>
           <a:p>
             <a:pPr algn="l">
@@ -4535,6 +4572,7 @@
                 <a:latin typeface="Trebuchet MS"/>
               </a:defRPr>
             </a:pPr>
+            <a:endParaRPr/>
           </a:p>
           <a:p>
             <a:pPr algn="l">
@@ -4596,6 +4634,7 @@
                 <a:latin typeface="Trebuchet MS"/>
               </a:defRPr>
             </a:pPr>
+            <a:endParaRPr/>
           </a:p>
           <a:p>
             <a:pPr algn="l">
@@ -4656,7 +4695,7 @@
 </file>
 
 <file path=ppt/slides/slide14.xml><?xml version="1.0" encoding="utf-8"?>
-<p:sld xmlns:a="http://schemas.openxmlformats.org/drawingml/2006/main" xmlns:p="http://schemas.openxmlformats.org/presentationml/2006/main" xmlns:r="http://schemas.openxmlformats.org/officeDocument/2006/relationships">
+<p:sld xmlns:a="http://schemas.openxmlformats.org/drawingml/2006/main" xmlns:r="http://schemas.openxmlformats.org/officeDocument/2006/relationships" xmlns:p="http://schemas.openxmlformats.org/presentationml/2006/main">
   <p:cSld>
     <p:spTree>
       <p:nvGrpSpPr>
@@ -4664,7 +4703,14 @@
         <p:cNvGrpSpPr/>
         <p:nvPr/>
       </p:nvGrpSpPr>
-      <p:grpSpPr/>
+      <p:grpSpPr>
+        <a:xfrm>
+          <a:off x="0" y="0"/>
+          <a:ext cx="0" cy="0"/>
+          <a:chOff x="0" y="0"/>
+          <a:chExt cx="0" cy="0"/>
+        </a:xfrm>
+      </p:grpSpPr>
       <p:sp>
         <p:nvSpPr>
           <p:cNvPr id="2" name="TextBox 1"/>
@@ -4858,6 +4904,7 @@
                 <a:latin typeface="Trebuchet MS"/>
               </a:defRPr>
             </a:pPr>
+            <a:endParaRPr/>
           </a:p>
           <a:p>
             <a:pPr algn="l">
@@ -4887,6 +4934,7 @@
                 <a:latin typeface="Trebuchet MS"/>
               </a:defRPr>
             </a:pPr>
+            <a:endParaRPr/>
           </a:p>
           <a:p>
             <a:pPr algn="l">
@@ -4980,6 +5028,7 @@
                 <a:latin typeface="Trebuchet MS"/>
               </a:defRPr>
             </a:pPr>
+            <a:endParaRPr/>
           </a:p>
           <a:p>
             <a:pPr algn="l">
@@ -5025,6 +5074,7 @@
                 <a:latin typeface="Trebuchet MS"/>
               </a:defRPr>
             </a:pPr>
+            <a:endParaRPr/>
           </a:p>
           <a:p>
             <a:pPr algn="l">
@@ -5053,7 +5103,7 @@
 </file>
 
 <file path=ppt/slides/slide15.xml><?xml version="1.0" encoding="utf-8"?>
-<p:sld xmlns:a="http://schemas.openxmlformats.org/drawingml/2006/main" xmlns:p="http://schemas.openxmlformats.org/presentationml/2006/main" xmlns:r="http://schemas.openxmlformats.org/officeDocument/2006/relationships">
+<p:sld xmlns:a="http://schemas.openxmlformats.org/drawingml/2006/main" xmlns:r="http://schemas.openxmlformats.org/officeDocument/2006/relationships" xmlns:p="http://schemas.openxmlformats.org/presentationml/2006/main">
   <p:cSld>
     <p:bg>
       <p:bgPr>
@@ -5069,7 +5119,14 @@
         <p:cNvGrpSpPr/>
         <p:nvPr/>
       </p:nvGrpSpPr>
-      <p:grpSpPr/>
+      <p:grpSpPr>
+        <a:xfrm>
+          <a:off x="0" y="0"/>
+          <a:ext cx="0" cy="0"/>
+          <a:chOff x="0" y="0"/>
+          <a:chExt cx="0" cy="0"/>
+        </a:xfrm>
+      </p:grpSpPr>
       <p:sp>
         <p:nvSpPr>
           <p:cNvPr id="2" name="TextBox 1"/>
@@ -5151,7 +5208,7 @@
 </file>
 
 <file path=ppt/slides/slide16.xml><?xml version="1.0" encoding="utf-8"?>
-<p:sld xmlns:a="http://schemas.openxmlformats.org/drawingml/2006/main" xmlns:p="http://schemas.openxmlformats.org/presentationml/2006/main" xmlns:r="http://schemas.openxmlformats.org/officeDocument/2006/relationships">
+<p:sld xmlns:a="http://schemas.openxmlformats.org/drawingml/2006/main" xmlns:r="http://schemas.openxmlformats.org/officeDocument/2006/relationships" xmlns:p="http://schemas.openxmlformats.org/presentationml/2006/main">
   <p:cSld>
     <p:spTree>
       <p:nvGrpSpPr>
@@ -5159,7 +5216,14 @@
         <p:cNvGrpSpPr/>
         <p:nvPr/>
       </p:nvGrpSpPr>
-      <p:grpSpPr/>
+      <p:grpSpPr>
+        <a:xfrm>
+          <a:off x="0" y="0"/>
+          <a:ext cx="0" cy="0"/>
+          <a:chOff x="0" y="0"/>
+          <a:chExt cx="0" cy="0"/>
+        </a:xfrm>
+      </p:grpSpPr>
       <p:sp>
         <p:nvSpPr>
           <p:cNvPr id="2" name="TextBox 1"/>
@@ -5353,6 +5417,7 @@
                 <a:latin typeface="Trebuchet MS"/>
               </a:defRPr>
             </a:pPr>
+            <a:endParaRPr/>
           </a:p>
           <a:p>
             <a:pPr algn="l">
@@ -5398,6 +5463,7 @@
                 <a:latin typeface="Trebuchet MS"/>
               </a:defRPr>
             </a:pPr>
+            <a:endParaRPr/>
           </a:p>
           <a:p>
             <a:pPr algn="l">
@@ -5443,6 +5509,7 @@
                 <a:latin typeface="Trebuchet MS"/>
               </a:defRPr>
             </a:pPr>
+            <a:endParaRPr/>
           </a:p>
           <a:p>
             <a:pPr algn="l">
@@ -5488,6 +5555,7 @@
                 <a:latin typeface="Trebuchet MS"/>
               </a:defRPr>
             </a:pPr>
+            <a:endParaRPr/>
           </a:p>
           <a:p>
             <a:pPr algn="l">
@@ -5532,7 +5600,7 @@
 </file>
 
 <file path=ppt/slides/slide17.xml><?xml version="1.0" encoding="utf-8"?>
-<p:sld xmlns:a="http://schemas.openxmlformats.org/drawingml/2006/main" xmlns:p="http://schemas.openxmlformats.org/presentationml/2006/main" xmlns:r="http://schemas.openxmlformats.org/officeDocument/2006/relationships">
+<p:sld xmlns:a="http://schemas.openxmlformats.org/drawingml/2006/main" xmlns:r="http://schemas.openxmlformats.org/officeDocument/2006/relationships" xmlns:p="http://schemas.openxmlformats.org/presentationml/2006/main">
   <p:cSld>
     <p:spTree>
       <p:nvGrpSpPr>
@@ -5540,7 +5608,14 @@
         <p:cNvGrpSpPr/>
         <p:nvPr/>
       </p:nvGrpSpPr>
-      <p:grpSpPr/>
+      <p:grpSpPr>
+        <a:xfrm>
+          <a:off x="0" y="0"/>
+          <a:ext cx="0" cy="0"/>
+          <a:chOff x="0" y="0"/>
+          <a:chExt cx="0" cy="0"/>
+        </a:xfrm>
+      </p:grpSpPr>
       <p:sp>
         <p:nvSpPr>
           <p:cNvPr id="2" name="TextBox 1"/>
@@ -5734,6 +5809,7 @@
                 <a:latin typeface="Trebuchet MS"/>
               </a:defRPr>
             </a:pPr>
+            <a:endParaRPr/>
           </a:p>
           <a:p>
             <a:pPr algn="l">
@@ -5898,6 +5974,7 @@
                 <a:latin typeface="Trebuchet MS"/>
               </a:defRPr>
             </a:pPr>
+            <a:endParaRPr/>
           </a:p>
           <a:p>
             <a:pPr algn="l">
@@ -6022,7 +6099,7 @@
 </file>
 
 <file path=ppt/slides/slide18.xml><?xml version="1.0" encoding="utf-8"?>
-<p:sld xmlns:a="http://schemas.openxmlformats.org/drawingml/2006/main" xmlns:p="http://schemas.openxmlformats.org/presentationml/2006/main" xmlns:r="http://schemas.openxmlformats.org/officeDocument/2006/relationships">
+<p:sld xmlns:a="http://schemas.openxmlformats.org/drawingml/2006/main" xmlns:r="http://schemas.openxmlformats.org/officeDocument/2006/relationships" xmlns:p="http://schemas.openxmlformats.org/presentationml/2006/main">
   <p:cSld>
     <p:spTree>
       <p:nvGrpSpPr>
@@ -6030,7 +6107,14 @@
         <p:cNvGrpSpPr/>
         <p:nvPr/>
       </p:nvGrpSpPr>
-      <p:grpSpPr/>
+      <p:grpSpPr>
+        <a:xfrm>
+          <a:off x="0" y="0"/>
+          <a:ext cx="0" cy="0"/>
+          <a:chOff x="0" y="0"/>
+          <a:chExt cx="0" cy="0"/>
+        </a:xfrm>
+      </p:grpSpPr>
       <p:sp>
         <p:nvSpPr>
           <p:cNvPr id="2" name="TextBox 1"/>
@@ -6224,6 +6308,7 @@
                 <a:latin typeface="Trebuchet MS"/>
               </a:defRPr>
             </a:pPr>
+            <a:endParaRPr/>
           </a:p>
           <a:p>
             <a:pPr algn="l">
@@ -6340,6 +6425,7 @@
                 <a:latin typeface="Trebuchet MS"/>
               </a:defRPr>
             </a:pPr>
+            <a:endParaRPr/>
           </a:p>
           <a:p>
             <a:pPr algn="l">
@@ -6455,7 +6541,7 @@
 </file>
 
 <file path=ppt/slides/slide19.xml><?xml version="1.0" encoding="utf-8"?>
-<p:sld xmlns:a="http://schemas.openxmlformats.org/drawingml/2006/main" xmlns:p="http://schemas.openxmlformats.org/presentationml/2006/main" xmlns:r="http://schemas.openxmlformats.org/officeDocument/2006/relationships">
+<p:sld xmlns:a="http://schemas.openxmlformats.org/drawingml/2006/main" xmlns:r="http://schemas.openxmlformats.org/officeDocument/2006/relationships" xmlns:p="http://schemas.openxmlformats.org/presentationml/2006/main">
   <p:cSld>
     <p:bg>
       <p:bgPr>
@@ -6471,7 +6557,14 @@
         <p:cNvGrpSpPr/>
         <p:nvPr/>
       </p:nvGrpSpPr>
-      <p:grpSpPr/>
+      <p:grpSpPr>
+        <a:xfrm>
+          <a:off x="0" y="0"/>
+          <a:ext cx="0" cy="0"/>
+          <a:chOff x="0" y="0"/>
+          <a:chExt cx="0" cy="0"/>
+        </a:xfrm>
+      </p:grpSpPr>
       <p:sp>
         <p:nvSpPr>
           <p:cNvPr id="2" name="TextBox 1"/>
@@ -6517,7 +6610,7 @@
 </file>
 
 <file path=ppt/slides/slide2.xml><?xml version="1.0" encoding="utf-8"?>
-<p:sld xmlns:a="http://schemas.openxmlformats.org/drawingml/2006/main" xmlns:p="http://schemas.openxmlformats.org/presentationml/2006/main" xmlns:r="http://schemas.openxmlformats.org/officeDocument/2006/relationships">
+<p:sld xmlns:a="http://schemas.openxmlformats.org/drawingml/2006/main" xmlns:r="http://schemas.openxmlformats.org/officeDocument/2006/relationships" xmlns:p="http://schemas.openxmlformats.org/presentationml/2006/main">
   <p:cSld>
     <p:spTree>
       <p:nvGrpSpPr>
@@ -6525,7 +6618,14 @@
         <p:cNvGrpSpPr/>
         <p:nvPr/>
       </p:nvGrpSpPr>
-      <p:grpSpPr/>
+      <p:grpSpPr>
+        <a:xfrm>
+          <a:off x="0" y="0"/>
+          <a:ext cx="0" cy="0"/>
+          <a:chOff x="0" y="0"/>
+          <a:chExt cx="0" cy="0"/>
+        </a:xfrm>
+      </p:grpSpPr>
       <p:sp>
         <p:nvSpPr>
           <p:cNvPr id="2" name="TextBox 1"/>
@@ -6735,6 +6835,7 @@
                 <a:latin typeface="Trebuchet MS"/>
               </a:defRPr>
             </a:pPr>
+            <a:endParaRPr/>
           </a:p>
           <a:p>
             <a:pPr algn="l">
@@ -6780,6 +6881,7 @@
                 <a:latin typeface="Trebuchet MS"/>
               </a:defRPr>
             </a:pPr>
+            <a:endParaRPr/>
           </a:p>
           <a:p>
             <a:pPr algn="l">
@@ -6825,6 +6927,7 @@
                 <a:latin typeface="Trebuchet MS"/>
               </a:defRPr>
             </a:pPr>
+            <a:endParaRPr/>
           </a:p>
           <a:p>
             <a:pPr algn="l">
@@ -6885,7 +6988,7 @@
 </file>
 
 <file path=ppt/slides/slide20.xml><?xml version="1.0" encoding="utf-8"?>
-<p:sld xmlns:a="http://schemas.openxmlformats.org/drawingml/2006/main" xmlns:p="http://schemas.openxmlformats.org/presentationml/2006/main" xmlns:r="http://schemas.openxmlformats.org/officeDocument/2006/relationships">
+<p:sld xmlns:a="http://schemas.openxmlformats.org/drawingml/2006/main" xmlns:r="http://schemas.openxmlformats.org/officeDocument/2006/relationships" xmlns:p="http://schemas.openxmlformats.org/presentationml/2006/main">
   <p:cSld>
     <p:spTree>
       <p:nvGrpSpPr>
@@ -6893,7 +6996,14 @@
         <p:cNvGrpSpPr/>
         <p:nvPr/>
       </p:nvGrpSpPr>
-      <p:grpSpPr/>
+      <p:grpSpPr>
+        <a:xfrm>
+          <a:off x="0" y="0"/>
+          <a:ext cx="0" cy="0"/>
+          <a:chOff x="0" y="0"/>
+          <a:chExt cx="0" cy="0"/>
+        </a:xfrm>
+      </p:grpSpPr>
       <p:sp>
         <p:nvSpPr>
           <p:cNvPr id="2" name="TextBox 1"/>
@@ -7103,6 +7213,7 @@
                 <a:latin typeface="Trebuchet MS"/>
               </a:defRPr>
             </a:pPr>
+            <a:endParaRPr/>
           </a:p>
           <a:p>
             <a:pPr algn="l">
@@ -7148,6 +7259,7 @@
                 <a:latin typeface="Trebuchet MS"/>
               </a:defRPr>
             </a:pPr>
+            <a:endParaRPr/>
           </a:p>
           <a:p>
             <a:pPr algn="l">
@@ -7193,6 +7305,7 @@
                 <a:latin typeface="Trebuchet MS"/>
               </a:defRPr>
             </a:pPr>
+            <a:endParaRPr/>
           </a:p>
           <a:p>
             <a:pPr algn="l">
@@ -7238,6 +7351,7 @@
                 <a:latin typeface="Trebuchet MS"/>
               </a:defRPr>
             </a:pPr>
+            <a:endParaRPr/>
           </a:p>
           <a:p>
             <a:pPr algn="l">
@@ -7282,7 +7396,7 @@
 </file>
 
 <file path=ppt/slides/slide21.xml><?xml version="1.0" encoding="utf-8"?>
-<p:sld xmlns:a="http://schemas.openxmlformats.org/drawingml/2006/main" xmlns:p="http://schemas.openxmlformats.org/presentationml/2006/main" xmlns:r="http://schemas.openxmlformats.org/officeDocument/2006/relationships">
+<p:sld xmlns:a="http://schemas.openxmlformats.org/drawingml/2006/main" xmlns:r="http://schemas.openxmlformats.org/officeDocument/2006/relationships" xmlns:p="http://schemas.openxmlformats.org/presentationml/2006/main">
   <p:cSld>
     <p:bg>
       <p:bgPr>
@@ -7298,7 +7412,14 @@
         <p:cNvGrpSpPr/>
         <p:nvPr/>
       </p:nvGrpSpPr>
-      <p:grpSpPr/>
+      <p:grpSpPr>
+        <a:xfrm>
+          <a:off x="0" y="0"/>
+          <a:ext cx="0" cy="0"/>
+          <a:chOff x="0" y="0"/>
+          <a:chExt cx="0" cy="0"/>
+        </a:xfrm>
+      </p:grpSpPr>
       <p:sp>
         <p:nvSpPr>
           <p:cNvPr id="2" name="TextBox 1"/>
@@ -7380,7 +7501,7 @@
         <p:spPr>
           <a:xfrm>
             <a:off x="502920" y="3200400"/>
-            <a:ext cx="8229600" cy="1371600"/>
+            <a:ext cx="8229600" cy="723275"/>
           </a:xfrm>
           <a:prstGeom prst="rect">
             <a:avLst/>
@@ -7405,6 +7526,7 @@
               </a:defRPr>
             </a:pPr>
             <a:r>
+              <a:rPr dirty="0"/>
               <a:t>Good luck with your presentations.</a:t>
             </a:r>
           </a:p>
@@ -7421,6 +7543,7 @@
               </a:defRPr>
             </a:pPr>
             <a:r>
+              <a:rPr dirty="0"/>
               <a:t>I’m excited to see what you built.</a:t>
             </a:r>
           </a:p>
@@ -7436,22 +7559,7 @@
                 <a:latin typeface="Trebuchet MS"/>
               </a:defRPr>
             </a:pPr>
-          </a:p>
-          <a:p>
-            <a:pPr algn="l">
-              <a:spcAft>
-                <a:spcPts val="300"/>
-              </a:spcAft>
-              <a:defRPr sz="1200" b="0">
-                <a:solidFill>
-                  <a:srgbClr val="8A95A7"/>
-                </a:solidFill>
-                <a:latin typeface="Trebuchet MS"/>
-              </a:defRPr>
-            </a:pPr>
-            <a:r>
-              <a:t>Office hours remain open through finals week.</a:t>
-            </a:r>
+            <a:endParaRPr dirty="0"/>
           </a:p>
         </p:txBody>
       </p:sp>
@@ -7464,7 +7572,7 @@
 </file>
 
 <file path=ppt/slides/slide22.xml><?xml version="1.0" encoding="utf-8"?>
-<p:sld xmlns:a="http://schemas.openxmlformats.org/drawingml/2006/main" xmlns:p="http://schemas.openxmlformats.org/presentationml/2006/main" xmlns:r="http://schemas.openxmlformats.org/officeDocument/2006/relationships">
+<p:sld xmlns:a="http://schemas.openxmlformats.org/drawingml/2006/main" xmlns:r="http://schemas.openxmlformats.org/officeDocument/2006/relationships" xmlns:p="http://schemas.openxmlformats.org/presentationml/2006/main">
   <p:cSld>
     <p:spTree>
       <p:nvGrpSpPr>
@@ -7472,7 +7580,14 @@
         <p:cNvGrpSpPr/>
         <p:nvPr/>
       </p:nvGrpSpPr>
-      <p:grpSpPr/>
+      <p:grpSpPr>
+        <a:xfrm>
+          <a:off x="0" y="0"/>
+          <a:ext cx="0" cy="0"/>
+          <a:chOff x="0" y="0"/>
+          <a:chExt cx="0" cy="0"/>
+        </a:xfrm>
+      </p:grpSpPr>
       <p:sp>
         <p:nvSpPr>
           <p:cNvPr id="2" name="TextBox 1"/>
@@ -7590,7 +7705,7 @@
         <p:spPr>
           <a:xfrm>
             <a:off x="502920" y="1097280"/>
-            <a:ext cx="8229600" cy="3200400"/>
+            <a:ext cx="8229600" cy="1962076"/>
           </a:xfrm>
           <a:prstGeom prst="rect">
             <a:avLst/>
@@ -7615,6 +7730,7 @@
               </a:defRPr>
             </a:pPr>
             <a:r>
+              <a:rPr dirty="0"/>
               <a:t>Please fill out the course evaluation.</a:t>
             </a:r>
           </a:p>
@@ -7630,6 +7746,7 @@
                 <a:latin typeface="Trebuchet MS"/>
               </a:defRPr>
             </a:pPr>
+            <a:endParaRPr dirty="0"/>
           </a:p>
           <a:p>
             <a:pPr algn="l">
@@ -7644,6 +7761,7 @@
               </a:defRPr>
             </a:pPr>
             <a:r>
+              <a:rPr dirty="0"/>
               <a:t>This is a brand-new course. Your feedback directly shapes</a:t>
             </a:r>
           </a:p>
@@ -7660,6 +7778,7 @@
               </a:defRPr>
             </a:pPr>
             <a:r>
+              <a:rPr dirty="0"/>
               <a:t>whether it runs again and how it improves.</a:t>
             </a:r>
           </a:p>
@@ -7675,6 +7794,7 @@
                 <a:latin typeface="Trebuchet MS"/>
               </a:defRPr>
             </a:pPr>
+            <a:endParaRPr dirty="0"/>
           </a:p>
           <a:p>
             <a:pPr algn="l">
@@ -7689,6 +7809,7 @@
               </a:defRPr>
             </a:pPr>
             <a:r>
+              <a:rPr dirty="0"/>
               <a:t>What worked?  What didn’t?  What would you change?</a:t>
             </a:r>
           </a:p>
@@ -7704,6 +7825,7 @@
                 <a:latin typeface="Trebuchet MS"/>
               </a:defRPr>
             </a:pPr>
+            <a:endParaRPr dirty="0"/>
           </a:p>
           <a:p>
             <a:pPr algn="l">
@@ -7718,7 +7840,8 @@
               </a:defRPr>
             </a:pPr>
             <a:r>
-              <a:t>Be honest. Be specific. Be constructive.</a:t>
+              <a:rPr dirty="0"/>
+              <a:t>Be specific. Be constructive.</a:t>
             </a:r>
           </a:p>
         </p:txBody>
@@ -7732,7 +7855,7 @@
 </file>
 
 <file path=ppt/slides/slide3.xml><?xml version="1.0" encoding="utf-8"?>
-<p:sld xmlns:a="http://schemas.openxmlformats.org/drawingml/2006/main" xmlns:p="http://schemas.openxmlformats.org/presentationml/2006/main" xmlns:r="http://schemas.openxmlformats.org/officeDocument/2006/relationships">
+<p:sld xmlns:a="http://schemas.openxmlformats.org/drawingml/2006/main" xmlns:r="http://schemas.openxmlformats.org/officeDocument/2006/relationships" xmlns:p="http://schemas.openxmlformats.org/presentationml/2006/main">
   <p:cSld>
     <p:spTree>
       <p:nvGrpSpPr>
@@ -7740,7 +7863,14 @@
         <p:cNvGrpSpPr/>
         <p:nvPr/>
       </p:nvGrpSpPr>
-      <p:grpSpPr/>
+      <p:grpSpPr>
+        <a:xfrm>
+          <a:off x="0" y="0"/>
+          <a:ext cx="0" cy="0"/>
+          <a:chOff x="0" y="0"/>
+          <a:chExt cx="0" cy="0"/>
+        </a:xfrm>
+      </p:grpSpPr>
       <p:sp>
         <p:nvSpPr>
           <p:cNvPr id="2" name="TextBox 1"/>
@@ -9101,7 +9231,7 @@
 </file>
 
 <file path=ppt/slides/slide4.xml><?xml version="1.0" encoding="utf-8"?>
-<p:sld xmlns:a="http://schemas.openxmlformats.org/drawingml/2006/main" xmlns:p="http://schemas.openxmlformats.org/presentationml/2006/main" xmlns:r="http://schemas.openxmlformats.org/officeDocument/2006/relationships">
+<p:sld xmlns:a="http://schemas.openxmlformats.org/drawingml/2006/main" xmlns:r="http://schemas.openxmlformats.org/officeDocument/2006/relationships" xmlns:p="http://schemas.openxmlformats.org/presentationml/2006/main">
   <p:cSld>
     <p:spTree>
       <p:nvGrpSpPr>
@@ -9109,7 +9239,14 @@
         <p:cNvGrpSpPr/>
         <p:nvPr/>
       </p:nvGrpSpPr>
-      <p:grpSpPr/>
+      <p:grpSpPr>
+        <a:xfrm>
+          <a:off x="0" y="0"/>
+          <a:ext cx="0" cy="0"/>
+          <a:chOff x="0" y="0"/>
+          <a:chExt cx="0" cy="0"/>
+        </a:xfrm>
+      </p:grpSpPr>
       <p:sp>
         <p:nvSpPr>
           <p:cNvPr id="2" name="TextBox 1"/>
@@ -9335,6 +9472,7 @@
                 <a:latin typeface="Trebuchet MS"/>
               </a:defRPr>
             </a:pPr>
+            <a:endParaRPr/>
           </a:p>
           <a:p>
             <a:pPr algn="l">
@@ -9396,6 +9534,7 @@
                 <a:latin typeface="Trebuchet MS"/>
               </a:defRPr>
             </a:pPr>
+            <a:endParaRPr/>
           </a:p>
           <a:p>
             <a:pPr algn="l">
@@ -9560,6 +9699,7 @@
                 <a:latin typeface="Trebuchet MS"/>
               </a:defRPr>
             </a:pPr>
+            <a:endParaRPr/>
           </a:p>
           <a:p>
             <a:pPr algn="l">
@@ -9621,6 +9761,7 @@
                 <a:latin typeface="Trebuchet MS"/>
               </a:defRPr>
             </a:pPr>
+            <a:endParaRPr/>
           </a:p>
           <a:p>
             <a:pPr algn="l">
@@ -9681,7 +9822,7 @@
 </file>
 
 <file path=ppt/slides/slide5.xml><?xml version="1.0" encoding="utf-8"?>
-<p:sld xmlns:a="http://schemas.openxmlformats.org/drawingml/2006/main" xmlns:p="http://schemas.openxmlformats.org/presentationml/2006/main" xmlns:r="http://schemas.openxmlformats.org/officeDocument/2006/relationships">
+<p:sld xmlns:a="http://schemas.openxmlformats.org/drawingml/2006/main" xmlns:r="http://schemas.openxmlformats.org/officeDocument/2006/relationships" xmlns:p="http://schemas.openxmlformats.org/presentationml/2006/main">
   <p:cSld>
     <p:spTree>
       <p:nvGrpSpPr>
@@ -9689,7 +9830,14 @@
         <p:cNvGrpSpPr/>
         <p:nvPr/>
       </p:nvGrpSpPr>
-      <p:grpSpPr/>
+      <p:grpSpPr>
+        <a:xfrm>
+          <a:off x="0" y="0"/>
+          <a:ext cx="0" cy="0"/>
+          <a:chOff x="0" y="0"/>
+          <a:chExt cx="0" cy="0"/>
+        </a:xfrm>
+      </p:grpSpPr>
       <p:sp>
         <p:nvSpPr>
           <p:cNvPr id="2" name="TextBox 1"/>
@@ -9883,6 +10031,7 @@
                 <a:latin typeface="Trebuchet MS"/>
               </a:defRPr>
             </a:pPr>
+            <a:endParaRPr/>
           </a:p>
           <a:p>
             <a:pPr algn="l">
@@ -9912,6 +10061,7 @@
                 <a:latin typeface="Trebuchet MS"/>
               </a:defRPr>
             </a:pPr>
+            <a:endParaRPr/>
           </a:p>
           <a:p>
             <a:pPr algn="l">
@@ -9973,6 +10123,7 @@
                 <a:latin typeface="Trebuchet MS"/>
               </a:defRPr>
             </a:pPr>
+            <a:endParaRPr/>
           </a:p>
           <a:p>
             <a:pPr algn="l">
@@ -10066,6 +10217,7 @@
                 <a:latin typeface="Trebuchet MS"/>
               </a:defRPr>
             </a:pPr>
+            <a:endParaRPr/>
           </a:p>
           <a:p>
             <a:pPr algn="l">
@@ -10094,7 +10246,7 @@
 </file>
 
 <file path=ppt/slides/slide6.xml><?xml version="1.0" encoding="utf-8"?>
-<p:sld xmlns:a="http://schemas.openxmlformats.org/drawingml/2006/main" xmlns:p="http://schemas.openxmlformats.org/presentationml/2006/main" xmlns:r="http://schemas.openxmlformats.org/officeDocument/2006/relationships">
+<p:sld xmlns:a="http://schemas.openxmlformats.org/drawingml/2006/main" xmlns:r="http://schemas.openxmlformats.org/officeDocument/2006/relationships" xmlns:p="http://schemas.openxmlformats.org/presentationml/2006/main">
   <p:cSld>
     <p:bg>
       <p:bgPr>
@@ -10110,7 +10262,14 @@
         <p:cNvGrpSpPr/>
         <p:nvPr/>
       </p:nvGrpSpPr>
-      <p:grpSpPr/>
+      <p:grpSpPr>
+        <a:xfrm>
+          <a:off x="0" y="0"/>
+          <a:ext cx="0" cy="0"/>
+          <a:chOff x="0" y="0"/>
+          <a:chExt cx="0" cy="0"/>
+        </a:xfrm>
+      </p:grpSpPr>
       <p:sp>
         <p:nvSpPr>
           <p:cNvPr id="2" name="TextBox 1"/>
@@ -10192,7 +10351,7 @@
 </file>
 
 <file path=ppt/slides/slide7.xml><?xml version="1.0" encoding="utf-8"?>
-<p:sld xmlns:a="http://schemas.openxmlformats.org/drawingml/2006/main" xmlns:p="http://schemas.openxmlformats.org/presentationml/2006/main" xmlns:r="http://schemas.openxmlformats.org/officeDocument/2006/relationships">
+<p:sld xmlns:a="http://schemas.openxmlformats.org/drawingml/2006/main" xmlns:r="http://schemas.openxmlformats.org/officeDocument/2006/relationships" xmlns:p="http://schemas.openxmlformats.org/presentationml/2006/main">
   <p:cSld>
     <p:spTree>
       <p:nvGrpSpPr>
@@ -10200,7 +10359,14 @@
         <p:cNvGrpSpPr/>
         <p:nvPr/>
       </p:nvGrpSpPr>
-      <p:grpSpPr/>
+      <p:grpSpPr>
+        <a:xfrm>
+          <a:off x="0" y="0"/>
+          <a:ext cx="0" cy="0"/>
+          <a:chOff x="0" y="0"/>
+          <a:chExt cx="0" cy="0"/>
+        </a:xfrm>
+      </p:grpSpPr>
       <p:sp>
         <p:nvSpPr>
           <p:cNvPr id="2" name="TextBox 1"/>
@@ -10426,6 +10592,7 @@
                 <a:latin typeface="Trebuchet MS"/>
               </a:defRPr>
             </a:pPr>
+            <a:endParaRPr/>
           </a:p>
           <a:p>
             <a:pPr algn="l">
@@ -10503,6 +10670,7 @@
                 <a:latin typeface="Trebuchet MS"/>
               </a:defRPr>
             </a:pPr>
+            <a:endParaRPr/>
           </a:p>
           <a:p>
             <a:pPr algn="l">
@@ -10564,6 +10732,7 @@
                 <a:latin typeface="Trebuchet MS"/>
               </a:defRPr>
             </a:pPr>
+            <a:endParaRPr/>
           </a:p>
           <a:p>
             <a:pPr algn="l">
@@ -10592,7 +10761,7 @@
 </file>
 
 <file path=ppt/slides/slide8.xml><?xml version="1.0" encoding="utf-8"?>
-<p:sld xmlns:a="http://schemas.openxmlformats.org/drawingml/2006/main" xmlns:p="http://schemas.openxmlformats.org/presentationml/2006/main" xmlns:r="http://schemas.openxmlformats.org/officeDocument/2006/relationships">
+<p:sld xmlns:a="http://schemas.openxmlformats.org/drawingml/2006/main" xmlns:r="http://schemas.openxmlformats.org/officeDocument/2006/relationships" xmlns:p="http://schemas.openxmlformats.org/presentationml/2006/main">
   <p:cSld>
     <p:spTree>
       <p:nvGrpSpPr>
@@ -10600,7 +10769,14 @@
         <p:cNvGrpSpPr/>
         <p:nvPr/>
       </p:nvGrpSpPr>
-      <p:grpSpPr/>
+      <p:grpSpPr>
+        <a:xfrm>
+          <a:off x="0" y="0"/>
+          <a:ext cx="0" cy="0"/>
+          <a:chOff x="0" y="0"/>
+          <a:chExt cx="0" cy="0"/>
+        </a:xfrm>
+      </p:grpSpPr>
       <p:sp>
         <p:nvSpPr>
           <p:cNvPr id="2" name="TextBox 1"/>
@@ -10842,6 +11018,7 @@
                 <a:latin typeface="Trebuchet MS"/>
               </a:defRPr>
             </a:pPr>
+            <a:endParaRPr/>
           </a:p>
           <a:p>
             <a:pPr algn="l">
@@ -10919,6 +11096,7 @@
                 <a:latin typeface="Trebuchet MS"/>
               </a:defRPr>
             </a:pPr>
+            <a:endParaRPr/>
           </a:p>
           <a:p>
             <a:pPr algn="l">
@@ -10980,6 +11158,7 @@
                 <a:latin typeface="Trebuchet MS"/>
               </a:defRPr>
             </a:pPr>
+            <a:endParaRPr/>
           </a:p>
           <a:p>
             <a:pPr algn="l">
@@ -11008,7 +11187,7 @@
 </file>
 
 <file path=ppt/slides/slide9.xml><?xml version="1.0" encoding="utf-8"?>
-<p:sld xmlns:a="http://schemas.openxmlformats.org/drawingml/2006/main" xmlns:p="http://schemas.openxmlformats.org/presentationml/2006/main" xmlns:r="http://schemas.openxmlformats.org/officeDocument/2006/relationships">
+<p:sld xmlns:a="http://schemas.openxmlformats.org/drawingml/2006/main" xmlns:r="http://schemas.openxmlformats.org/officeDocument/2006/relationships" xmlns:p="http://schemas.openxmlformats.org/presentationml/2006/main">
   <p:cSld>
     <p:spTree>
       <p:nvGrpSpPr>
@@ -11016,7 +11195,14 @@
         <p:cNvGrpSpPr/>
         <p:nvPr/>
       </p:nvGrpSpPr>
-      <p:grpSpPr/>
+      <p:grpSpPr>
+        <a:xfrm>
+          <a:off x="0" y="0"/>
+          <a:ext cx="0" cy="0"/>
+          <a:chOff x="0" y="0"/>
+          <a:chExt cx="0" cy="0"/>
+        </a:xfrm>
+      </p:grpSpPr>
       <p:sp>
         <p:nvSpPr>
           <p:cNvPr id="2" name="TextBox 1"/>
@@ -11242,6 +11428,7 @@
                 <a:latin typeface="Trebuchet MS"/>
               </a:defRPr>
             </a:pPr>
+            <a:endParaRPr/>
           </a:p>
           <a:p>
             <a:pPr algn="l">
@@ -11319,6 +11506,7 @@
                 <a:latin typeface="Trebuchet MS"/>
               </a:defRPr>
             </a:pPr>
+            <a:endParaRPr/>
           </a:p>
           <a:p>
             <a:pPr algn="l">
@@ -11380,6 +11568,7 @@
                 <a:latin typeface="Trebuchet MS"/>
               </a:defRPr>
             </a:pPr>
+            <a:endParaRPr/>
           </a:p>
           <a:p>
             <a:pPr algn="l">

</xml_diff>